<commit_message>
minor reorganization of slides
</commit_message>
<xml_diff>
--- a/slides/03-intro-to-sklearn.pptx
+++ b/slides/03-intro-to-sklearn.pptx
@@ -5,24 +5,26 @@
     <p:sldMasterId id="2147483686" r:id="rId1"/>
   </p:sldMasterIdLst>
   <p:notesMasterIdLst>
-    <p:notesMasterId r:id="rId17"/>
+    <p:notesMasterId r:id="rId19"/>
   </p:notesMasterIdLst>
   <p:sldIdLst>
     <p:sldId id="256" r:id="rId2"/>
-    <p:sldId id="321" r:id="rId3"/>
-    <p:sldId id="322" r:id="rId4"/>
-    <p:sldId id="323" r:id="rId5"/>
-    <p:sldId id="329" r:id="rId6"/>
-    <p:sldId id="330" r:id="rId7"/>
-    <p:sldId id="328" r:id="rId8"/>
-    <p:sldId id="324" r:id="rId9"/>
-    <p:sldId id="325" r:id="rId10"/>
-    <p:sldId id="326" r:id="rId11"/>
-    <p:sldId id="327" r:id="rId12"/>
+    <p:sldId id="335" r:id="rId3"/>
+    <p:sldId id="321" r:id="rId4"/>
+    <p:sldId id="328" r:id="rId5"/>
+    <p:sldId id="322" r:id="rId6"/>
+    <p:sldId id="323" r:id="rId7"/>
+    <p:sldId id="329" r:id="rId8"/>
+    <p:sldId id="330" r:id="rId9"/>
+    <p:sldId id="324" r:id="rId10"/>
+    <p:sldId id="325" r:id="rId11"/>
+    <p:sldId id="326" r:id="rId12"/>
     <p:sldId id="331" r:id="rId13"/>
     <p:sldId id="332" r:id="rId14"/>
     <p:sldId id="333" r:id="rId15"/>
     <p:sldId id="334" r:id="rId16"/>
+    <p:sldId id="336" r:id="rId17"/>
+    <p:sldId id="327" r:id="rId18"/>
   </p:sldIdLst>
   <p:sldSz cx="12192000" cy="6858000"/>
   <p:notesSz cx="6858000" cy="9144000"/>
@@ -211,7 +213,7 @@
           <a:p>
             <a:fld id="{A5320152-7289-42ED-97D3-BBB411F9F8C0}" type="datetimeFigureOut">
               <a:rPr lang="en-US" smtClean="0"/>
-              <a:t>8/31/2026</a:t>
+              <a:t>9/9/2026</a:t>
             </a:fld>
             <a:endParaRPr lang="en-US"/>
           </a:p>
@@ -631,7 +633,7 @@
           <a:p>
             <a:fld id="{D1D1EADE-8E88-4C7C-8AC5-FB148DE4940E}" type="datetime1">
               <a:rPr lang="en-US" smtClean="0"/>
-              <a:t>8/31/2026</a:t>
+              <a:t>9/9/2026</a:t>
             </a:fld>
             <a:endParaRPr lang="en-US"/>
           </a:p>
@@ -831,7 +833,7 @@
           <a:p>
             <a:fld id="{EC3C8B9C-477D-492A-96AD-1FC2CC997A73}" type="datetime1">
               <a:rPr lang="en-US" smtClean="0"/>
-              <a:t>8/31/2026</a:t>
+              <a:t>9/9/2026</a:t>
             </a:fld>
             <a:endParaRPr lang="en-US"/>
           </a:p>
@@ -1041,7 +1043,7 @@
           <a:p>
             <a:fld id="{42D3AED5-E26D-4E29-B1B3-7847B6779594}" type="datetime1">
               <a:rPr lang="en-US" smtClean="0"/>
-              <a:t>8/31/2026</a:t>
+              <a:t>9/9/2026</a:t>
             </a:fld>
             <a:endParaRPr lang="en-US"/>
           </a:p>
@@ -1536,7 +1538,7 @@
           <a:p>
             <a:fld id="{157B6794-849E-4626-908B-D15793550EFB}" type="datetime1">
               <a:rPr lang="en-US" smtClean="0"/>
-              <a:t>8/31/2026</a:t>
+              <a:t>9/9/2026</a:t>
             </a:fld>
             <a:endParaRPr lang="en-US"/>
           </a:p>
@@ -1812,7 +1814,7 @@
           <a:p>
             <a:fld id="{63DB64E7-5594-42A3-ADBF-E95A7ACEAD64}" type="datetime1">
               <a:rPr lang="en-US" smtClean="0"/>
-              <a:t>8/31/2026</a:t>
+              <a:t>9/9/2026</a:t>
             </a:fld>
             <a:endParaRPr lang="en-US"/>
           </a:p>
@@ -2085,7 +2087,7 @@
           <a:p>
             <a:fld id="{18462B0B-D248-4FFB-8695-AD7FA4B1284A}" type="datetime1">
               <a:rPr lang="en-US" smtClean="0"/>
-              <a:t>8/31/2026</a:t>
+              <a:t>9/9/2026</a:t>
             </a:fld>
             <a:endParaRPr lang="en-US"/>
           </a:p>
@@ -2508,7 +2510,7 @@
           <a:p>
             <a:fld id="{D0378EFB-9159-4510-B73F-4F0409ADE937}" type="datetime1">
               <a:rPr lang="en-US" smtClean="0"/>
-              <a:t>8/31/2026</a:t>
+              <a:t>9/9/2026</a:t>
             </a:fld>
             <a:endParaRPr lang="en-US"/>
           </a:p>
@@ -2650,7 +2652,7 @@
           <a:p>
             <a:fld id="{89BC9412-2452-4BED-A324-9D8C115361AD}" type="datetime1">
               <a:rPr lang="en-US" smtClean="0"/>
-              <a:t>8/31/2026</a:t>
+              <a:t>9/9/2026</a:t>
             </a:fld>
             <a:endParaRPr lang="en-US"/>
           </a:p>
@@ -2763,7 +2765,7 @@
           <a:p>
             <a:fld id="{F5318F62-D251-40E8-A23C-F4CFE9FEAB41}" type="datetime1">
               <a:rPr lang="en-US" smtClean="0"/>
-              <a:t>8/31/2026</a:t>
+              <a:t>9/9/2026</a:t>
             </a:fld>
             <a:endParaRPr lang="en-US"/>
           </a:p>
@@ -3076,7 +3078,7 @@
           <a:p>
             <a:fld id="{44F76144-149E-4874-93A5-554A0357CF82}" type="datetime1">
               <a:rPr lang="en-US" smtClean="0"/>
-              <a:t>8/31/2026</a:t>
+              <a:t>9/9/2026</a:t>
             </a:fld>
             <a:endParaRPr lang="en-US"/>
           </a:p>
@@ -3369,7 +3371,7 @@
           <a:p>
             <a:fld id="{50BA65D8-0540-4835-AE5C-25D29DBA01BE}" type="datetime1">
               <a:rPr lang="en-US" smtClean="0"/>
-              <a:t>8/31/2026</a:t>
+              <a:t>9/9/2026</a:t>
             </a:fld>
             <a:endParaRPr lang="en-US"/>
           </a:p>
@@ -3611,7 +3613,7 @@
           <a:p>
             <a:fld id="{E31BA835-12AC-4E8F-955A-EA3F4DE2791F}" type="datetime1">
               <a:rPr lang="en-US" smtClean="0"/>
-              <a:t>8/31/2026</a:t>
+              <a:t>9/9/2026</a:t>
             </a:fld>
             <a:endParaRPr lang="en-US"/>
           </a:p>
@@ -4492,6 +4494,234 @@
       </p:grpSpPr>
       <p:sp>
         <p:nvSpPr>
+          <p:cNvPr id="649" name="Preparing your data"/>
+          <p:cNvSpPr txBox="1">
+            <a:spLocks noGrp="1"/>
+          </p:cNvSpPr>
+          <p:nvPr>
+            <p:ph type="title"/>
+          </p:nvPr>
+        </p:nvSpPr>
+        <p:spPr>
+          <a:prstGeom prst="rect">
+            <a:avLst/>
+          </a:prstGeom>
+        </p:spPr>
+        <p:txBody>
+          <a:bodyPr/>
+          <a:lstStyle/>
+          <a:p>
+            <a:r>
+              <a:rPr dirty="0"/>
+              <a:t>Preparing your data</a:t>
+            </a:r>
+          </a:p>
+        </p:txBody>
+      </p:sp>
+      <p:sp>
+        <p:nvSpPr>
+          <p:cNvPr id="650" name="The data should be in tabular form…"/>
+          <p:cNvSpPr txBox="1">
+            <a:spLocks noGrp="1"/>
+          </p:cNvSpPr>
+          <p:nvPr>
+            <p:ph type="body" idx="1"/>
+          </p:nvPr>
+        </p:nvSpPr>
+        <p:spPr>
+          <a:xfrm>
+            <a:off x="700634" y="1714998"/>
+            <a:ext cx="10691265" cy="3739896"/>
+          </a:xfrm>
+          <a:prstGeom prst="rect">
+            <a:avLst/>
+          </a:prstGeom>
+        </p:spPr>
+        <p:txBody>
+          <a:bodyPr>
+            <a:normAutofit/>
+          </a:bodyPr>
+          <a:lstStyle/>
+          <a:p>
+            <a:r>
+              <a:rPr lang="en-US"/>
+              <a:t>The data should be in tabular form </a:t>
+            </a:r>
+          </a:p>
+          <a:p>
+            <a:pPr lvl="2"/>
+            <a:r>
+              <a:rPr lang="en-US" sz="2000" dirty="0"/>
+              <a:t>G</a:t>
+            </a:r>
+            <a:r>
+              <a:rPr lang="en-US" sz="2000"/>
+              <a:t>enerally</a:t>
+            </a:r>
+            <a:r>
+              <a:rPr lang="en-US" sz="2000" dirty="0"/>
+              <a:t>,</a:t>
+            </a:r>
+            <a:r>
+              <a:rPr lang="en-US" sz="2000"/>
+              <a:t> NumPy or </a:t>
+            </a:r>
+            <a:r>
+              <a:rPr lang="en-US" sz="2000" dirty="0"/>
+              <a:t>Pandas</a:t>
+            </a:r>
+            <a:r>
+              <a:rPr lang="en-US" sz="2000"/>
+              <a:t> </a:t>
+            </a:r>
+            <a:r>
+              <a:rPr lang="en-US" sz="2000" dirty="0"/>
+              <a:t>objects</a:t>
+            </a:r>
+            <a:endParaRPr lang="en-US" sz="2000"/>
+          </a:p>
+          <a:p>
+            <a:pPr lvl="2"/>
+            <a:r>
+              <a:rPr lang="en-US" sz="2000"/>
+              <a:t>The rows should be the observations or samples</a:t>
+            </a:r>
+          </a:p>
+          <a:p>
+            <a:r>
+              <a:rPr lang="en-US"/>
+              <a:t>The feature matrix (X) should be a </a:t>
+            </a:r>
+            <a:r>
+              <a:rPr lang="en-US">
+                <a:solidFill>
+                  <a:srgbClr val="FF7E79"/>
+                </a:solidFill>
+              </a:rPr>
+              <a:t>2D </a:t>
+            </a:r>
+            <a:r>
+              <a:rPr lang="en-US"/>
+              <a:t>NumPy array or a </a:t>
+            </a:r>
+            <a:r>
+              <a:rPr lang="en-US" dirty="0"/>
+              <a:t>Pandas</a:t>
+            </a:r>
+            <a:r>
+              <a:rPr lang="en-US"/>
+              <a:t> </a:t>
+            </a:r>
+            <a:r>
+              <a:rPr lang="en-US">
+                <a:solidFill>
+                  <a:srgbClr val="FF7E79"/>
+                </a:solidFill>
+              </a:rPr>
+              <a:t>DataFrame</a:t>
+            </a:r>
+            <a:r>
+              <a:rPr lang="en-US"/>
+              <a:t> </a:t>
+            </a:r>
+          </a:p>
+          <a:p>
+            <a:pPr lvl="2"/>
+            <a:r>
+              <a:rPr lang="en-US" sz="2000"/>
+              <a:t>This applies even when there is only 1 feature</a:t>
+            </a:r>
+            <a:endParaRPr lang="en-US" sz="2000" dirty="0"/>
+          </a:p>
+          <a:p>
+            <a:pPr lvl="2"/>
+            <a:r>
+              <a:rPr lang="en-US" sz="2000" b="1" dirty="0"/>
+              <a:t>Note</a:t>
+            </a:r>
+            <a:r>
+              <a:rPr lang="en-US" sz="2000" dirty="0"/>
+              <a:t>: if only one feature, it often must be reshaped using </a:t>
+            </a:r>
+            <a:r>
+              <a:rPr lang="en-US" sz="2000" dirty="0">
+                <a:latin typeface="Courier"/>
+              </a:rPr>
+              <a:t>.reshape(-1, 1)</a:t>
+            </a:r>
+            <a:endParaRPr lang="en-US" sz="2000">
+              <a:latin typeface="Courier"/>
+            </a:endParaRPr>
+          </a:p>
+          <a:p>
+            <a:r>
+              <a:rPr lang="en-US"/>
+              <a:t>The target (y) should be a </a:t>
+            </a:r>
+            <a:r>
+              <a:rPr lang="en-US">
+                <a:solidFill>
+                  <a:srgbClr val="FF7E79"/>
+                </a:solidFill>
+              </a:rPr>
+              <a:t>1D</a:t>
+            </a:r>
+            <a:r>
+              <a:rPr lang="en-US"/>
+              <a:t> NumPy array or a </a:t>
+            </a:r>
+            <a:r>
+              <a:rPr lang="en-US" dirty="0"/>
+              <a:t>Pandas</a:t>
+            </a:r>
+            <a:r>
+              <a:rPr lang="en-US"/>
+              <a:t> </a:t>
+            </a:r>
+            <a:r>
+              <a:rPr lang="en-US">
+                <a:solidFill>
+                  <a:srgbClr val="FF7E79"/>
+                </a:solidFill>
+              </a:rPr>
+              <a:t>Series</a:t>
+            </a:r>
+            <a:endParaRPr dirty="0">
+              <a:solidFill>
+                <a:srgbClr val="FF7E79"/>
+              </a:solidFill>
+            </a:endParaRPr>
+          </a:p>
+        </p:txBody>
+      </p:sp>
+    </p:spTree>
+  </p:cSld>
+  <p:clrMapOvr>
+    <a:masterClrMapping/>
+  </p:clrMapOvr>
+  <p:transition spd="med"/>
+</p:sld>
+</file>
+
+<file path=ppt/slides/slide11.xml><?xml version="1.0" encoding="utf-8"?>
+<p:sld xmlns:a="http://schemas.openxmlformats.org/drawingml/2006/main" xmlns:r="http://schemas.openxmlformats.org/officeDocument/2006/relationships" xmlns:p="http://schemas.openxmlformats.org/presentationml/2006/main">
+  <p:cSld>
+    <p:spTree>
+      <p:nvGrpSpPr>
+        <p:cNvPr id="1" name=""/>
+        <p:cNvGrpSpPr/>
+        <p:nvPr/>
+      </p:nvGrpSpPr>
+      <p:grpSpPr>
+        <a:xfrm>
+          <a:off x="0" y="0"/>
+          <a:ext cx="0" cy="0"/>
+          <a:chOff x="0" y="0"/>
+          <a:chExt cx="0" cy="0"/>
+        </a:xfrm>
+      </p:grpSpPr>
+      <p:sp>
+        <p:nvSpPr>
           <p:cNvPr id="5" name="Rectangle: Rounded Corners 4">
             <a:extLst>
               <a:ext uri="{FF2B5EF4-FFF2-40B4-BE49-F238E27FC236}">
@@ -5785,114 +6015,6 @@
 </p:sld>
 </file>
 
-<file path=ppt/slides/slide11.xml><?xml version="1.0" encoding="utf-8"?>
-<p:sld xmlns:a="http://schemas.openxmlformats.org/drawingml/2006/main" xmlns:r="http://schemas.openxmlformats.org/officeDocument/2006/relationships" xmlns:p="http://schemas.openxmlformats.org/presentationml/2006/main">
-  <p:cSld>
-    <p:spTree>
-      <p:nvGrpSpPr>
-        <p:cNvPr id="1" name=""/>
-        <p:cNvGrpSpPr/>
-        <p:nvPr/>
-      </p:nvGrpSpPr>
-      <p:grpSpPr>
-        <a:xfrm>
-          <a:off x="0" y="0"/>
-          <a:ext cx="0" cy="0"/>
-          <a:chOff x="0" y="0"/>
-          <a:chExt cx="0" cy="0"/>
-        </a:xfrm>
-      </p:grpSpPr>
-      <p:sp>
-        <p:nvSpPr>
-          <p:cNvPr id="656" name="Become friends with the documentation"/>
-          <p:cNvSpPr txBox="1">
-            <a:spLocks noGrp="1"/>
-          </p:cNvSpPr>
-          <p:nvPr>
-            <p:ph type="title"/>
-          </p:nvPr>
-        </p:nvSpPr>
-        <p:spPr>
-          <a:prstGeom prst="rect">
-            <a:avLst/>
-          </a:prstGeom>
-        </p:spPr>
-        <p:txBody>
-          <a:bodyPr>
-            <a:normAutofit/>
-          </a:bodyPr>
-          <a:lstStyle>
-            <a:lvl1pPr defTabSz="208279">
-              <a:defRPr sz="4920" spc="-49"/>
-            </a:lvl1pPr>
-          </a:lstStyle>
-          <a:p>
-            <a:r>
-              <a:rPr lang="en-US" dirty="0"/>
-              <a:t>Review </a:t>
-            </a:r>
-            <a:r>
-              <a:rPr dirty="0"/>
-              <a:t>the documentation</a:t>
-            </a:r>
-            <a:r>
-              <a:rPr lang="en-US" dirty="0"/>
-              <a:t>!</a:t>
-            </a:r>
-            <a:endParaRPr dirty="0"/>
-          </a:p>
-        </p:txBody>
-      </p:sp>
-      <p:sp>
-        <p:nvSpPr>
-          <p:cNvPr id="657" name="A large part of learning Scikit-Learn is getting comfortable with the documentation…"/>
-          <p:cNvSpPr txBox="1">
-            <a:spLocks noGrp="1"/>
-          </p:cNvSpPr>
-          <p:nvPr>
-            <p:ph type="body" idx="1"/>
-          </p:nvPr>
-        </p:nvSpPr>
-        <p:spPr>
-          <a:prstGeom prst="rect">
-            <a:avLst/>
-          </a:prstGeom>
-        </p:spPr>
-        <p:txBody>
-          <a:bodyPr/>
-          <a:lstStyle/>
-          <a:p>
-            <a:r>
-              <a:rPr dirty="0"/>
-              <a:t>A large part of learning Scikit-Learn is getting comfortable with the documentation</a:t>
-            </a:r>
-          </a:p>
-          <a:p>
-            <a:r>
-              <a:rPr dirty="0"/>
-              <a:t>The documentation is vast and sometimes intimidating but learning how to read it will help you know how to implement the right model for your situation</a:t>
-            </a:r>
-          </a:p>
-          <a:p>
-            <a:r>
-              <a:rPr dirty="0">
-                <a:hlinkClick r:id="rId2"/>
-              </a:rPr>
-              <a:t>https://scikit-learn.org/stable/</a:t>
-            </a:r>
-            <a:endParaRPr dirty="0"/>
-          </a:p>
-        </p:txBody>
-      </p:sp>
-    </p:spTree>
-  </p:cSld>
-  <p:clrMapOvr>
-    <a:masterClrMapping/>
-  </p:clrMapOvr>
-  <p:transition spd="med"/>
-</p:sld>
-</file>
-
 <file path=ppt/slides/slide12.xml><?xml version="1.0" encoding="utf-8"?>
 <p:sld xmlns:a="http://schemas.openxmlformats.org/drawingml/2006/main" xmlns:r="http://schemas.openxmlformats.org/officeDocument/2006/relationships" xmlns:p="http://schemas.openxmlformats.org/presentationml/2006/main" show="0">
   <p:cSld>
@@ -6602,9 +6724,10 @@
           <a:lstStyle/>
           <a:p>
             <a:r>
-              <a:rPr dirty="0"/>
-              <a:t>different steps for different columns</a:t>
-            </a:r>
+              <a:rPr lang="en-US"/>
+              <a:t>Different steps for different columns</a:t>
+            </a:r>
+            <a:endParaRPr dirty="0"/>
           </a:p>
         </p:txBody>
       </p:sp>
@@ -7277,6 +7400,247 @@
 </p:sld>
 </file>
 
+<file path=ppt/slides/slide16.xml><?xml version="1.0" encoding="utf-8"?>
+<p:sld xmlns:a="http://schemas.openxmlformats.org/drawingml/2006/main" xmlns:r="http://schemas.openxmlformats.org/officeDocument/2006/relationships" xmlns:p="http://schemas.openxmlformats.org/presentationml/2006/main">
+  <p:cSld>
+    <p:spTree>
+      <p:nvGrpSpPr>
+        <p:cNvPr id="1" name=""/>
+        <p:cNvGrpSpPr/>
+        <p:nvPr/>
+      </p:nvGrpSpPr>
+      <p:grpSpPr>
+        <a:xfrm>
+          <a:off x="0" y="0"/>
+          <a:ext cx="0" cy="0"/>
+          <a:chOff x="0" y="0"/>
+          <a:chExt cx="0" cy="0"/>
+        </a:xfrm>
+      </p:grpSpPr>
+      <p:sp>
+        <p:nvSpPr>
+          <p:cNvPr id="3" name="Title 2"/>
+          <p:cNvSpPr>
+            <a:spLocks noGrp="1"/>
+          </p:cNvSpPr>
+          <p:nvPr>
+            <p:ph type="title"/>
+          </p:nvPr>
+        </p:nvSpPr>
+        <p:spPr/>
+        <p:txBody>
+          <a:bodyPr/>
+          <a:lstStyle/>
+          <a:p>
+            <a:r>
+              <a:rPr lang="en-US"/>
+              <a:t>Putting it together</a:t>
+            </a:r>
+            <a:endParaRPr/>
+          </a:p>
+        </p:txBody>
+      </p:sp>
+      <p:sp>
+        <p:nvSpPr>
+          <p:cNvPr id="4" name="Text Placeholder 3"/>
+          <p:cNvSpPr>
+            <a:spLocks noGrp="1"/>
+          </p:cNvSpPr>
+          <p:nvPr>
+            <p:ph type="body" idx="1"/>
+          </p:nvPr>
+        </p:nvSpPr>
+        <p:spPr/>
+        <p:txBody>
+          <a:bodyPr wrap="square" lIns="73152" tIns="36576" rIns="54864" bIns="36576" anchor="t"/>
+          <a:lstStyle/>
+          <a:p>
+            <a:pPr>
+              <a:spcAft>
+                <a:spcPts val="700"/>
+              </a:spcAft>
+              <a:defRPr sz="2300" b="1">
+                <a:solidFill>
+                  <a:srgbClr val="734B67"/>
+                </a:solidFill>
+                <a:latin typeface="Calisto MT"/>
+              </a:defRPr>
+            </a:pPr>
+            <a:r>
+              <a:rPr lang="en-US"/>
+              <a:t>Every model is an object with state and a shared interface</a:t>
+            </a:r>
+          </a:p>
+          <a:p>
+            <a:pPr>
+              <a:spcAft>
+                <a:spcPts val="700"/>
+              </a:spcAft>
+              <a:defRPr sz="2300" b="1">
+                <a:solidFill>
+                  <a:srgbClr val="734B67"/>
+                </a:solidFill>
+                <a:latin typeface="Calisto MT"/>
+              </a:defRPr>
+            </a:pPr>
+            <a:r>
+              <a:rPr lang="en-US"/>
+              <a:t>Learn one API and you can use nearly any model in the library</a:t>
+            </a:r>
+          </a:p>
+          <a:p>
+            <a:pPr>
+              <a:spcAft>
+                <a:spcPts val="700"/>
+              </a:spcAft>
+              <a:defRPr sz="2300" b="1">
+                <a:solidFill>
+                  <a:srgbClr val="734B67"/>
+                </a:solidFill>
+                <a:latin typeface="Calisto MT"/>
+              </a:defRPr>
+            </a:pPr>
+            <a:r>
+              <a:rPr lang="en-US"/>
+              <a:t>Fit on training data, apply with .predict() or .transform()</a:t>
+            </a:r>
+          </a:p>
+          <a:p>
+            <a:pPr>
+              <a:spcAft>
+                <a:spcPts val="700"/>
+              </a:spcAft>
+              <a:defRPr sz="2300" b="1">
+                <a:solidFill>
+                  <a:srgbClr val="734B67"/>
+                </a:solidFill>
+                <a:latin typeface="Calisto MT"/>
+              </a:defRPr>
+            </a:pPr>
+            <a:r>
+              <a:rPr lang="en-US"/>
+              <a:t>Wrap preprocessing and modeling in a pipeline to keep evaluation honest</a:t>
+            </a:r>
+            <a:endParaRPr/>
+          </a:p>
+        </p:txBody>
+      </p:sp>
+    </p:spTree>
+  </p:cSld>
+  <p:clrMapOvr>
+    <a:masterClrMapping/>
+  </p:clrMapOvr>
+</p:sld>
+</file>
+
+<file path=ppt/slides/slide17.xml><?xml version="1.0" encoding="utf-8"?>
+<p:sld xmlns:a="http://schemas.openxmlformats.org/drawingml/2006/main" xmlns:r="http://schemas.openxmlformats.org/officeDocument/2006/relationships" xmlns:p="http://schemas.openxmlformats.org/presentationml/2006/main">
+  <p:cSld>
+    <p:spTree>
+      <p:nvGrpSpPr>
+        <p:cNvPr id="1" name=""/>
+        <p:cNvGrpSpPr/>
+        <p:nvPr/>
+      </p:nvGrpSpPr>
+      <p:grpSpPr>
+        <a:xfrm>
+          <a:off x="0" y="0"/>
+          <a:ext cx="0" cy="0"/>
+          <a:chOff x="0" y="0"/>
+          <a:chExt cx="0" cy="0"/>
+        </a:xfrm>
+      </p:grpSpPr>
+      <p:sp>
+        <p:nvSpPr>
+          <p:cNvPr id="656" name="Become friends with the documentation"/>
+          <p:cNvSpPr txBox="1">
+            <a:spLocks noGrp="1"/>
+          </p:cNvSpPr>
+          <p:nvPr>
+            <p:ph type="title"/>
+          </p:nvPr>
+        </p:nvSpPr>
+        <p:spPr>
+          <a:prstGeom prst="rect">
+            <a:avLst/>
+          </a:prstGeom>
+        </p:spPr>
+        <p:txBody>
+          <a:bodyPr>
+            <a:normAutofit/>
+          </a:bodyPr>
+          <a:lstStyle>
+            <a:lvl1pPr defTabSz="208279">
+              <a:defRPr sz="4920" spc="-49"/>
+            </a:lvl1pPr>
+          </a:lstStyle>
+          <a:p>
+            <a:r>
+              <a:rPr lang="en-US" dirty="0"/>
+              <a:t>Review </a:t>
+            </a:r>
+            <a:r>
+              <a:rPr dirty="0"/>
+              <a:t>the documentation</a:t>
+            </a:r>
+            <a:r>
+              <a:rPr lang="en-US" dirty="0"/>
+              <a:t>!</a:t>
+            </a:r>
+            <a:endParaRPr dirty="0"/>
+          </a:p>
+        </p:txBody>
+      </p:sp>
+      <p:sp>
+        <p:nvSpPr>
+          <p:cNvPr id="657" name="A large part of learning Scikit-Learn is getting comfortable with the documentation…"/>
+          <p:cNvSpPr txBox="1">
+            <a:spLocks noGrp="1"/>
+          </p:cNvSpPr>
+          <p:nvPr>
+            <p:ph type="body" idx="1"/>
+          </p:nvPr>
+        </p:nvSpPr>
+        <p:spPr>
+          <a:prstGeom prst="rect">
+            <a:avLst/>
+          </a:prstGeom>
+        </p:spPr>
+        <p:txBody>
+          <a:bodyPr/>
+          <a:lstStyle/>
+          <a:p>
+            <a:r>
+              <a:rPr dirty="0"/>
+              <a:t>A large part of learning Scikit-Learn is getting comfortable with the documentation</a:t>
+            </a:r>
+          </a:p>
+          <a:p>
+            <a:r>
+              <a:rPr dirty="0"/>
+              <a:t>The documentation is vast and sometimes intimidating but learning how to read it will help you know how to implement the right model for your situation</a:t>
+            </a:r>
+          </a:p>
+          <a:p>
+            <a:r>
+              <a:rPr dirty="0">
+                <a:hlinkClick r:id="rId2"/>
+              </a:rPr>
+              <a:t>https://scikit-learn.org/stable/</a:t>
+            </a:r>
+            <a:endParaRPr dirty="0"/>
+          </a:p>
+        </p:txBody>
+      </p:sp>
+    </p:spTree>
+  </p:cSld>
+  <p:clrMapOvr>
+    <a:masterClrMapping/>
+  </p:clrMapOvr>
+  <p:transition spd="med"/>
+</p:sld>
+</file>
+
 <file path=ppt/slides/slide2.xml><?xml version="1.0" encoding="utf-8"?>
 <p:sld xmlns:a="http://schemas.openxmlformats.org/drawingml/2006/main" xmlns:r="http://schemas.openxmlformats.org/officeDocument/2006/relationships" xmlns:p="http://schemas.openxmlformats.org/presentationml/2006/main">
   <p:cSld>
@@ -7296,186 +7660,126 @@
       </p:grpSpPr>
       <p:sp>
         <p:nvSpPr>
-          <p:cNvPr id="633" name="What is Scikit-Learn"/>
-          <p:cNvSpPr txBox="1">
+          <p:cNvPr id="3" name="Title 2"/>
+          <p:cNvSpPr>
             <a:spLocks noGrp="1"/>
           </p:cNvSpPr>
           <p:nvPr>
             <p:ph type="title"/>
           </p:nvPr>
         </p:nvSpPr>
-        <p:spPr>
-          <a:prstGeom prst="rect">
-            <a:avLst/>
-          </a:prstGeom>
-        </p:spPr>
+        <p:spPr/>
         <p:txBody>
           <a:bodyPr/>
           <a:lstStyle/>
           <a:p>
             <a:r>
-              <a:t>What is Scikit-Learn</a:t>
-            </a:r>
-          </a:p>
-        </p:txBody>
-      </p:sp>
-      <p:sp>
-        <p:nvSpPr>
-          <p:cNvPr id="634" name="Scikit-Learn is one of the best known python packages for machine learning…"/>
-          <p:cNvSpPr txBox="1">
+              <a:rPr lang="en-US"/>
+              <a:t>What we'll cover</a:t>
+            </a:r>
+            <a:endParaRPr/>
+          </a:p>
+        </p:txBody>
+      </p:sp>
+      <p:sp>
+        <p:nvSpPr>
+          <p:cNvPr id="4" name="Text Placeholder 3"/>
+          <p:cNvSpPr>
             <a:spLocks noGrp="1"/>
           </p:cNvSpPr>
           <p:nvPr>
             <p:ph type="body" idx="1"/>
           </p:nvPr>
         </p:nvSpPr>
-        <p:spPr>
-          <a:xfrm>
-            <a:off x="2015133" y="1871904"/>
-            <a:ext cx="8161734" cy="4759169"/>
-          </a:xfrm>
-          <a:prstGeom prst="rect">
-            <a:avLst/>
-          </a:prstGeom>
-        </p:spPr>
-        <p:txBody>
-          <a:bodyPr>
-            <a:normAutofit fontScale="77500" lnSpcReduction="20000"/>
-          </a:bodyPr>
+        <p:spPr/>
+        <p:txBody>
+          <a:bodyPr wrap="square" lIns="73152" tIns="36576" rIns="54864" bIns="36576" anchor="t"/>
           <a:lstStyle/>
           <a:p>
-            <a:pPr marL="221002" indent="-221002" defTabSz="176015">
-              <a:spcBef>
-                <a:spcPts val="2250"/>
-              </a:spcBef>
-              <a:defRPr sz="2772"/>
-            </a:pPr>
-            <a:r>
-              <a:rPr dirty="0"/>
-              <a:t>Scikit-Learn is one of the </a:t>
-            </a:r>
-            <a:r>
-              <a:rPr lang="en-US" dirty="0"/>
-              <a:t>best-known</a:t>
-            </a:r>
-            <a:r>
-              <a:rPr dirty="0"/>
-              <a:t> </a:t>
-            </a:r>
-            <a:r>
-              <a:rPr lang="en-US" dirty="0"/>
-              <a:t>Python</a:t>
-            </a:r>
-            <a:r>
-              <a:rPr dirty="0"/>
-              <a:t> packages for machine learning</a:t>
-            </a:r>
-          </a:p>
-          <a:p>
-            <a:pPr marL="221002" indent="-221002" defTabSz="176015">
-              <a:spcBef>
-                <a:spcPts val="2250"/>
-              </a:spcBef>
-              <a:defRPr sz="2772"/>
-            </a:pPr>
-            <a:r>
-              <a:rPr u="sng" dirty="0">
-                <a:hlinkClick r:id="rId2"/>
-              </a:rPr>
-              <a:t>scikit-learn.org</a:t>
-            </a:r>
-            <a:r>
-              <a:rPr dirty="0"/>
-              <a:t> </a:t>
-            </a:r>
-          </a:p>
-          <a:p>
-            <a:pPr marL="221002" indent="-221002" defTabSz="176015">
-              <a:spcBef>
-                <a:spcPts val="2250"/>
-              </a:spcBef>
-              <a:defRPr sz="2772"/>
-            </a:pPr>
-            <a:r>
-              <a:rPr dirty="0"/>
-              <a:t>It provides efficient versions of many common ML algorithms</a:t>
-            </a:r>
-          </a:p>
-          <a:p>
-            <a:pPr marL="221002" indent="-221002" defTabSz="176015">
-              <a:spcBef>
-                <a:spcPts val="2250"/>
-              </a:spcBef>
-              <a:defRPr sz="2772"/>
-            </a:pPr>
-            <a:r>
-              <a:rPr dirty="0"/>
-              <a:t>It has a clean, uniform, and streamlined API</a:t>
-            </a:r>
-          </a:p>
-          <a:p>
-            <a:pPr marL="664773" lvl="2" indent="-222770" defTabSz="176015">
-              <a:defRPr sz="2772"/>
-            </a:pPr>
-            <a:r>
-              <a:rPr dirty="0"/>
-              <a:t>Once you understand the syntax of Scikit-Learn, it is straightforward to use any model inside the library</a:t>
-            </a:r>
-          </a:p>
-          <a:p>
-            <a:pPr marL="221002" indent="-221002" defTabSz="176015">
-              <a:spcBef>
-                <a:spcPts val="2250"/>
-              </a:spcBef>
-              <a:defRPr sz="2772"/>
-            </a:pPr>
-            <a:r>
-              <a:rPr dirty="0"/>
-              <a:t>In </a:t>
-            </a:r>
-            <a:r>
-              <a:rPr lang="en-US" dirty="0"/>
-              <a:t>Python</a:t>
-            </a:r>
-            <a:r>
-              <a:rPr dirty="0"/>
-              <a:t>, Scikit-Learn is called with </a:t>
-            </a:r>
-            <a:r>
-              <a:rPr dirty="0" err="1">
-                <a:latin typeface="Courier"/>
-                <a:ea typeface="Courier"/>
-                <a:cs typeface="Courier"/>
-                <a:sym typeface="Courier"/>
-              </a:rPr>
-              <a:t>sklearn</a:t>
-            </a:r>
-            <a:r>
-              <a:rPr dirty="0"/>
-              <a:t>  </a:t>
-            </a:r>
-          </a:p>
-          <a:p>
-            <a:pPr marL="664773" lvl="2" indent="-222770" defTabSz="176015">
-              <a:spcBef>
-                <a:spcPts val="2250"/>
-              </a:spcBef>
-              <a:defRPr sz="2772" b="1">
-                <a:latin typeface="Courier New"/>
-                <a:ea typeface="Courier New"/>
-                <a:cs typeface="Courier New"/>
-                <a:sym typeface="Courier New"/>
+            <a:pPr>
+              <a:spcAft>
+                <a:spcPts val="700"/>
+              </a:spcAft>
+              <a:defRPr sz="2300" b="1">
+                <a:solidFill>
+                  <a:srgbClr val="734B67"/>
+                </a:solidFill>
+                <a:latin typeface="Calisto MT"/>
               </a:defRPr>
             </a:pPr>
             <a:r>
-              <a:rPr dirty="0"/>
-              <a:t>import </a:t>
-            </a:r>
-            <a:r>
-              <a:rPr dirty="0" err="1"/>
-              <a:t>sklearn</a:t>
-            </a:r>
-            <a:endParaRPr dirty="0"/>
+              <a:rPr lang="en-US"/>
+              <a:t>Scikit-Learn as an object-oriented library</a:t>
+            </a:r>
+          </a:p>
+          <a:p>
+            <a:pPr>
+              <a:spcAft>
+                <a:spcPts val="700"/>
+              </a:spcAft>
+              <a:defRPr sz="2300" b="1">
+                <a:solidFill>
+                  <a:srgbClr val="734B67"/>
+                </a:solidFill>
+                <a:latin typeface="Calisto MT"/>
+              </a:defRPr>
+            </a:pPr>
+            <a:r>
+              <a:rPr lang="en-US"/>
+              <a:t>The three core object types: estimators, transformers, predictors</a:t>
+            </a:r>
+          </a:p>
+          <a:p>
+            <a:pPr>
+              <a:spcAft>
+                <a:spcPts val="700"/>
+              </a:spcAft>
+              <a:defRPr sz="2300" b="1">
+                <a:solidFill>
+                  <a:srgbClr val="734B67"/>
+                </a:solidFill>
+                <a:latin typeface="Calisto MT"/>
+              </a:defRPr>
+            </a:pPr>
+            <a:r>
+              <a:rPr lang="en-US"/>
+              <a:t>Getting your data into the right shape</a:t>
+            </a:r>
+          </a:p>
+          <a:p>
+            <a:pPr>
+              <a:spcAft>
+                <a:spcPts val="700"/>
+              </a:spcAft>
+              <a:defRPr sz="2300" b="1">
+                <a:solidFill>
+                  <a:srgbClr val="734B67"/>
+                </a:solidFill>
+                <a:latin typeface="Calisto MT"/>
+              </a:defRPr>
+            </a:pPr>
+            <a:r>
+              <a:rPr lang="en-US"/>
+              <a:t>A worked modeling example</a:t>
+            </a:r>
+          </a:p>
+          <a:p>
+            <a:pPr>
+              <a:spcAft>
+                <a:spcPts val="700"/>
+              </a:spcAft>
+              <a:defRPr sz="2300" b="1">
+                <a:solidFill>
+                  <a:srgbClr val="734B67"/>
+                </a:solidFill>
+                <a:latin typeface="Calisto MT"/>
+              </a:defRPr>
+            </a:pPr>
+            <a:r>
+              <a:rPr lang="en-US"/>
+              <a:t>Pipelines: avoiding leakage and keeping workflows reproducible</a:t>
+            </a:r>
+            <a:endParaRPr/>
           </a:p>
         </p:txBody>
       </p:sp>
@@ -7484,7 +7788,6 @@
   <p:clrMapOvr>
     <a:masterClrMapping/>
   </p:clrMapOvr>
-  <p:transition spd="med"/>
 </p:sld>
 </file>
 
@@ -7507,163 +7810,71 @@
       </p:grpSpPr>
       <p:sp>
         <p:nvSpPr>
-          <p:cNvPr id="636" name="Scikit-Learn Design"/>
+          <p:cNvPr id="633" name="What is Scikit-Learn"/>
           <p:cNvSpPr txBox="1">
             <a:spLocks noGrp="1"/>
           </p:cNvSpPr>
           <p:nvPr>
             <p:ph type="title"/>
+          </p:nvPr>
+        </p:nvSpPr>
+        <p:spPr>
+          <a:prstGeom prst="rect">
+            <a:avLst/>
+          </a:prstGeom>
+        </p:spPr>
+        <p:txBody>
+          <a:bodyPr/>
+          <a:lstStyle/>
+          <a:p>
+            <a:r>
+              <a:t>What is Scikit-Learn</a:t>
+            </a:r>
+          </a:p>
+        </p:txBody>
+      </p:sp>
+      <p:sp>
+        <p:nvSpPr>
+          <p:cNvPr id="634" name="Scikit-Learn is one of the best known python packages for machine learning…"/>
+          <p:cNvSpPr txBox="1">
+            <a:spLocks noGrp="1"/>
+          </p:cNvSpPr>
+          <p:nvPr>
+            <p:ph type="body" idx="1"/>
           </p:nvPr>
         </p:nvSpPr>
         <p:spPr>
           <a:xfrm>
-            <a:off x="682528" y="832919"/>
-            <a:ext cx="10691265" cy="1307592"/>
+            <a:off x="2015133" y="1871904"/>
+            <a:ext cx="8161734" cy="4759169"/>
           </a:xfrm>
           <a:prstGeom prst="rect">
             <a:avLst/>
           </a:prstGeom>
         </p:spPr>
         <p:txBody>
-          <a:bodyPr/>
-          <a:lstStyle/>
-          <a:p>
-            <a:r>
-              <a:rPr dirty="0"/>
-              <a:t>Scikit-Learn Design</a:t>
-            </a:r>
-          </a:p>
-        </p:txBody>
-      </p:sp>
-      <p:sp>
-        <p:nvSpPr>
-          <p:cNvPr id="637" name="Consistency:   * All objects share a consistent and sensible interface…"/>
-          <p:cNvSpPr txBox="1">
-            <a:spLocks noGrp="1"/>
-          </p:cNvSpPr>
-          <p:nvPr>
-            <p:ph type="body" idx="1"/>
-          </p:nvPr>
-        </p:nvSpPr>
-        <p:spPr>
-          <a:xfrm>
-            <a:off x="2015133" y="1391768"/>
-            <a:ext cx="8161734" cy="4975099"/>
-          </a:xfrm>
-          <a:prstGeom prst="rect">
-            <a:avLst/>
-          </a:prstGeom>
-        </p:spPr>
-        <p:txBody>
           <a:bodyPr>
             <a:normAutofit fontScale="77500" lnSpcReduction="20000"/>
           </a:bodyPr>
           <a:lstStyle/>
           <a:p>
-            <a:pPr marL="203143" indent="-203143" defTabSz="161792">
+            <a:pPr marL="221002" indent="-221002" defTabSz="176015">
               <a:spcBef>
-                <a:spcPts val="2109"/>
+                <a:spcPts val="2250"/>
               </a:spcBef>
-              <a:defRPr sz="2548"/>
-            </a:pPr>
-            <a:r>
-              <a:rPr b="1" dirty="0">
-                <a:latin typeface="Graphik"/>
-                <a:ea typeface="Graphik"/>
-                <a:cs typeface="Graphik"/>
-                <a:sym typeface="Graphik"/>
-              </a:rPr>
-              <a:t>Consistency</a:t>
-            </a:r>
+              <a:defRPr sz="2772"/>
+            </a:pPr>
             <a:r>
               <a:rPr dirty="0"/>
-              <a:t>:  </a:t>
-            </a:r>
-            <a:br>
+              <a:t>Scikit-Learn is one of the </a:t>
+            </a:r>
+            <a:r>
+              <a:rPr lang="en-US" dirty="0"/>
+              <a:t>best-known</a:t>
+            </a:r>
+            <a:r>
               <a:rPr dirty="0"/>
-            </a:br>
-            <a:r>
-              <a:rPr dirty="0"/>
-              <a:t>* All objects share a consistent and sensible interface</a:t>
-            </a:r>
-          </a:p>
-          <a:p>
-            <a:pPr marL="203143" indent="-203143" defTabSz="161792">
-              <a:spcBef>
-                <a:spcPts val="2109"/>
-              </a:spcBef>
-              <a:defRPr sz="2548"/>
-            </a:pPr>
-            <a:r>
-              <a:rPr b="1" dirty="0">
-                <a:latin typeface="Graphik"/>
-                <a:ea typeface="Graphik"/>
-                <a:cs typeface="Graphik"/>
-                <a:sym typeface="Graphik"/>
-              </a:rPr>
-              <a:t>Inspection</a:t>
-            </a:r>
-            <a:r>
-              <a:rPr dirty="0"/>
-              <a:t>:  </a:t>
-            </a:r>
-            <a:br>
-              <a:rPr dirty="0"/>
-            </a:br>
-            <a:r>
-              <a:rPr dirty="0"/>
-              <a:t>* All hyperparameter and learned parameters are directly accessible (as attributes of the object)</a:t>
-            </a:r>
-            <a:br>
-              <a:rPr dirty="0"/>
-            </a:br>
-            <a:r>
-              <a:rPr dirty="0"/>
-              <a:t>* Learn parameters have an underscore suffix </a:t>
-            </a:r>
-          </a:p>
-          <a:p>
-            <a:pPr marL="203143" indent="-203143" defTabSz="161792">
-              <a:spcBef>
-                <a:spcPts val="2109"/>
-              </a:spcBef>
-              <a:defRPr sz="2548"/>
-            </a:pPr>
-            <a:r>
-              <a:rPr b="1" dirty="0">
-                <a:latin typeface="Graphik"/>
-                <a:ea typeface="Graphik"/>
-                <a:cs typeface="Graphik"/>
-                <a:sym typeface="Graphik"/>
-              </a:rPr>
-              <a:t>Nonproliferation of classes</a:t>
-            </a:r>
-            <a:r>
-              <a:rPr dirty="0"/>
-              <a:t>:</a:t>
-            </a:r>
-            <a:br>
-              <a:rPr dirty="0"/>
-            </a:br>
-            <a:r>
-              <a:rPr dirty="0"/>
-              <a:t>* Datasets and hyperparameters are </a:t>
-            </a:r>
-            <a:r>
-              <a:rPr lang="en-US" dirty="0"/>
-              <a:t>Pandas</a:t>
-            </a:r>
-            <a:r>
-              <a:rPr dirty="0"/>
-              <a:t>, </a:t>
-            </a:r>
-            <a:r>
-              <a:rPr lang="en-US" dirty="0" err="1"/>
-              <a:t>Numpy</a:t>
-            </a:r>
-            <a:r>
-              <a:rPr dirty="0"/>
-              <a:t>, or base </a:t>
+              <a:t> </a:t>
             </a:r>
             <a:r>
               <a:rPr lang="en-US" dirty="0"/>
@@ -7671,64 +7882,114 @@
             </a:r>
             <a:r>
               <a:rPr dirty="0"/>
-              <a:t> objects</a:t>
-            </a:r>
-          </a:p>
-          <a:p>
-            <a:pPr marL="203143" indent="-203143" defTabSz="161792">
+              <a:t> packages for machine learning</a:t>
+            </a:r>
+          </a:p>
+          <a:p>
+            <a:pPr marL="221002" indent="-221002" defTabSz="176015">
               <a:spcBef>
-                <a:spcPts val="2109"/>
+                <a:spcPts val="2250"/>
               </a:spcBef>
-              <a:defRPr sz="2548"/>
-            </a:pPr>
-            <a:r>
-              <a:rPr b="1" dirty="0">
-                <a:latin typeface="Graphik"/>
-                <a:ea typeface="Graphik"/>
-                <a:cs typeface="Graphik"/>
-                <a:sym typeface="Graphik"/>
-              </a:rPr>
-              <a:t>Composition</a:t>
+              <a:defRPr sz="2772"/>
+            </a:pPr>
+            <a:r>
+              <a:rPr u="sng" dirty="0">
+                <a:hlinkClick r:id="rId2"/>
+              </a:rPr>
+              <a:t>scikit-learn.org</a:t>
             </a:r>
             <a:r>
               <a:rPr dirty="0"/>
-              <a:t>:</a:t>
-            </a:r>
-            <a:br>
+              <a:t> </a:t>
+            </a:r>
+          </a:p>
+          <a:p>
+            <a:pPr marL="221002" indent="-221002" defTabSz="176015">
+              <a:spcBef>
+                <a:spcPts val="2250"/>
+              </a:spcBef>
+              <a:defRPr sz="2772"/>
+            </a:pPr>
+            <a:r>
               <a:rPr dirty="0"/>
-            </a:br>
+              <a:t>It provides efficient versions of many common ML algorithms</a:t>
+            </a:r>
+          </a:p>
+          <a:p>
+            <a:pPr marL="221002" indent="-221002" defTabSz="176015">
+              <a:spcBef>
+                <a:spcPts val="2250"/>
+              </a:spcBef>
+              <a:defRPr sz="2772"/>
+            </a:pPr>
             <a:r>
               <a:rPr dirty="0"/>
-              <a:t>* Existing building blocks are reused as much as possible </a:t>
-            </a:r>
-          </a:p>
-          <a:p>
-            <a:pPr marL="203143" indent="-203143" defTabSz="161792">
+              <a:t>It has a clean, uniform, and streamlined API</a:t>
+            </a:r>
+          </a:p>
+          <a:p>
+            <a:pPr marL="664773" lvl="2" indent="-222770" defTabSz="176015">
+              <a:defRPr sz="2772"/>
+            </a:pPr>
+            <a:r>
+              <a:rPr dirty="0"/>
+              <a:t>Once you understand the syntax of Scikit-Learn, it is straightforward to use any model inside the library</a:t>
+            </a:r>
+          </a:p>
+          <a:p>
+            <a:pPr marL="221002" indent="-221002" defTabSz="176015">
               <a:spcBef>
-                <a:spcPts val="2109"/>
+                <a:spcPts val="2250"/>
               </a:spcBef>
-              <a:defRPr sz="2548"/>
-            </a:pPr>
-            <a:r>
-              <a:rPr b="1" dirty="0">
-                <a:latin typeface="Graphik"/>
-                <a:ea typeface="Graphik"/>
-                <a:cs typeface="Graphik"/>
-                <a:sym typeface="Graphik"/>
-              </a:rPr>
-              <a:t>Sensible defaults</a:t>
-            </a:r>
+              <a:defRPr sz="2772"/>
+            </a:pPr>
             <a:r>
               <a:rPr dirty="0"/>
-              <a:t>:</a:t>
-            </a:r>
-            <a:br>
+              <a:t>In </a:t>
+            </a:r>
+            <a:r>
+              <a:rPr lang="en-US" dirty="0"/>
+              <a:t>Python</a:t>
+            </a:r>
+            <a:r>
               <a:rPr dirty="0"/>
-            </a:br>
+              <a:t>, Scikit-Learn is called with </a:t>
+            </a:r>
+            <a:r>
+              <a:rPr dirty="0" err="1">
+                <a:latin typeface="Courier"/>
+                <a:ea typeface="Courier"/>
+                <a:cs typeface="Courier"/>
+                <a:sym typeface="Courier"/>
+              </a:rPr>
+              <a:t>sklearn</a:t>
+            </a:r>
             <a:r>
               <a:rPr dirty="0"/>
-              <a:t>* Most parameters have reasonable default values</a:t>
-            </a:r>
+              <a:t>  </a:t>
+            </a:r>
+          </a:p>
+          <a:p>
+            <a:pPr marL="664773" lvl="2" indent="-222770" defTabSz="176015">
+              <a:spcBef>
+                <a:spcPts val="2250"/>
+              </a:spcBef>
+              <a:defRPr sz="2772" b="1">
+                <a:latin typeface="Courier New"/>
+                <a:ea typeface="Courier New"/>
+                <a:cs typeface="Courier New"/>
+                <a:sym typeface="Courier New"/>
+              </a:defRPr>
+            </a:pPr>
+            <a:r>
+              <a:rPr dirty="0"/>
+              <a:t>import </a:t>
+            </a:r>
+            <a:r>
+              <a:rPr dirty="0" err="1"/>
+              <a:t>sklearn</a:t>
+            </a:r>
+            <a:endParaRPr dirty="0"/>
           </a:p>
         </p:txBody>
       </p:sp>
@@ -7760,6 +8021,555 @@
       </p:grpSpPr>
       <p:sp>
         <p:nvSpPr>
+          <p:cNvPr id="2" name="Title 1">
+            <a:extLst>
+              <a:ext uri="{FF2B5EF4-FFF2-40B4-BE49-F238E27FC236}">
+                <a16:creationId xmlns:a16="http://schemas.microsoft.com/office/drawing/2014/main" id="{0EB25123-03AC-49EB-EA6D-74D26E76AC6F}"/>
+              </a:ext>
+            </a:extLst>
+          </p:cNvPr>
+          <p:cNvSpPr>
+            <a:spLocks noGrp="1"/>
+          </p:cNvSpPr>
+          <p:nvPr>
+            <p:ph type="title"/>
+          </p:nvPr>
+        </p:nvSpPr>
+        <p:spPr/>
+        <p:txBody>
+          <a:bodyPr/>
+          <a:lstStyle/>
+          <a:p>
+            <a:r>
+              <a:rPr lang="en-US" dirty="0"/>
+              <a:t>Object-oriented modeling</a:t>
+            </a:r>
+          </a:p>
+        </p:txBody>
+      </p:sp>
+      <p:sp>
+        <p:nvSpPr>
+          <p:cNvPr id="3" name="Content Placeholder 2">
+            <a:extLst>
+              <a:ext uri="{FF2B5EF4-FFF2-40B4-BE49-F238E27FC236}">
+                <a16:creationId xmlns:a16="http://schemas.microsoft.com/office/drawing/2014/main" id="{DC147735-00F0-8EBC-5C89-AC1921633E0E}"/>
+              </a:ext>
+            </a:extLst>
+          </p:cNvPr>
+          <p:cNvSpPr>
+            <a:spLocks noGrp="1"/>
+          </p:cNvSpPr>
+          <p:nvPr>
+            <p:ph sz="half" idx="1"/>
+          </p:nvPr>
+        </p:nvSpPr>
+        <p:spPr/>
+        <p:txBody>
+          <a:bodyPr>
+            <a:normAutofit fontScale="92500" lnSpcReduction="10000"/>
+          </a:bodyPr>
+          <a:lstStyle/>
+          <a:p>
+            <a:r>
+              <a:rPr lang="en-US" dirty="0"/>
+              <a:t>A model is an </a:t>
+            </a:r>
+            <a:r>
+              <a:rPr lang="en-US" b="1" dirty="0"/>
+              <a:t>object</a:t>
+            </a:r>
+            <a:r>
+              <a:rPr lang="en-US" dirty="0"/>
+              <a:t>:</a:t>
+            </a:r>
+          </a:p>
+          <a:p>
+            <a:pPr lvl="1"/>
+            <a:r>
+              <a:rPr lang="en-US" dirty="0"/>
+              <a:t>It has </a:t>
+            </a:r>
+            <a:r>
+              <a:rPr lang="en-US" b="1" dirty="0"/>
+              <a:t>state</a:t>
+            </a:r>
+            <a:r>
+              <a:rPr lang="en-US" dirty="0"/>
+              <a:t> (learned parameters)</a:t>
+            </a:r>
+          </a:p>
+          <a:p>
+            <a:pPr lvl="1"/>
+            <a:r>
+              <a:rPr lang="en-US" dirty="0"/>
+              <a:t>It has </a:t>
+            </a:r>
+            <a:r>
+              <a:rPr lang="en-US" b="1" dirty="0"/>
+              <a:t>methods</a:t>
+            </a:r>
+            <a:r>
+              <a:rPr lang="en-US" dirty="0"/>
+              <a:t> (fit, predict)</a:t>
+            </a:r>
+          </a:p>
+          <a:p>
+            <a:r>
+              <a:rPr lang="en-US" dirty="0"/>
+              <a:t>This allows:</a:t>
+            </a:r>
+          </a:p>
+          <a:p>
+            <a:pPr lvl="1"/>
+            <a:r>
+              <a:rPr lang="en-US" dirty="0"/>
+              <a:t>Reuse</a:t>
+            </a:r>
+          </a:p>
+          <a:p>
+            <a:pPr lvl="1"/>
+            <a:r>
+              <a:rPr lang="en-US" dirty="0"/>
+              <a:t>Inspection</a:t>
+            </a:r>
+          </a:p>
+          <a:p>
+            <a:pPr lvl="1"/>
+            <a:r>
+              <a:rPr lang="en-US" dirty="0"/>
+              <a:t>Composition (pipelines)</a:t>
+            </a:r>
+          </a:p>
+        </p:txBody>
+      </p:sp>
+      <p:sp>
+        <p:nvSpPr>
+          <p:cNvPr id="4" name="Content Placeholder 3">
+            <a:extLst>
+              <a:ext uri="{FF2B5EF4-FFF2-40B4-BE49-F238E27FC236}">
+                <a16:creationId xmlns:a16="http://schemas.microsoft.com/office/drawing/2014/main" id="{03E0D369-A01D-2EA7-0939-76A1FE027A5F}"/>
+              </a:ext>
+            </a:extLst>
+          </p:cNvPr>
+          <p:cNvSpPr>
+            <a:spLocks noGrp="1"/>
+          </p:cNvSpPr>
+          <p:nvPr>
+            <p:ph sz="half" idx="2"/>
+          </p:nvPr>
+        </p:nvSpPr>
+        <p:spPr/>
+        <p:txBody>
+          <a:bodyPr>
+            <a:normAutofit fontScale="92500" lnSpcReduction="10000"/>
+          </a:bodyPr>
+          <a:lstStyle/>
+          <a:p>
+            <a:pPr marL="0" indent="0">
+              <a:spcBef>
+                <a:spcPts val="0"/>
+              </a:spcBef>
+              <a:buNone/>
+            </a:pPr>
+            <a:r>
+              <a:rPr lang="en-US" dirty="0">
+                <a:latin typeface="Courier"/>
+              </a:rPr>
+              <a:t>from </a:t>
+            </a:r>
+            <a:r>
+              <a:rPr lang="en-US" dirty="0" err="1">
+                <a:latin typeface="Courier"/>
+              </a:rPr>
+              <a:t>sklearn.linear_model</a:t>
+            </a:r>
+            <a:r>
+              <a:rPr lang="en-US" dirty="0">
+                <a:latin typeface="Courier"/>
+              </a:rPr>
+              <a:t> import </a:t>
+            </a:r>
+            <a:r>
+              <a:rPr lang="en-US" dirty="0" err="1">
+                <a:latin typeface="Courier"/>
+              </a:rPr>
+              <a:t>LinearRegression</a:t>
+            </a:r>
+            <a:endParaRPr lang="en-US" dirty="0">
+              <a:latin typeface="Courier"/>
+            </a:endParaRPr>
+          </a:p>
+          <a:p>
+            <a:pPr marL="0" indent="0">
+              <a:spcBef>
+                <a:spcPts val="0"/>
+              </a:spcBef>
+              <a:buNone/>
+            </a:pPr>
+            <a:endParaRPr lang="en-US" dirty="0">
+              <a:latin typeface="Courier"/>
+            </a:endParaRPr>
+          </a:p>
+          <a:p>
+            <a:pPr marL="0" indent="0">
+              <a:spcBef>
+                <a:spcPts val="0"/>
+              </a:spcBef>
+              <a:buNone/>
+            </a:pPr>
+            <a:r>
+              <a:rPr lang="en-US" dirty="0">
+                <a:latin typeface="Courier"/>
+              </a:rPr>
+              <a:t># Model instantiation</a:t>
+            </a:r>
+          </a:p>
+          <a:p>
+            <a:pPr marL="0" indent="0">
+              <a:spcBef>
+                <a:spcPts val="0"/>
+              </a:spcBef>
+              <a:buNone/>
+            </a:pPr>
+            <a:r>
+              <a:rPr lang="en-US" dirty="0">
+                <a:latin typeface="Courier"/>
+              </a:rPr>
+              <a:t>model = </a:t>
+            </a:r>
+            <a:r>
+              <a:rPr lang="en-US" dirty="0" err="1">
+                <a:latin typeface="Courier"/>
+              </a:rPr>
+              <a:t>LinearRegression</a:t>
+            </a:r>
+            <a:r>
+              <a:rPr lang="en-US" dirty="0">
+                <a:latin typeface="Courier"/>
+              </a:rPr>
+              <a:t>()</a:t>
+            </a:r>
+          </a:p>
+          <a:p>
+            <a:pPr marL="0" indent="0">
+              <a:spcBef>
+                <a:spcPts val="0"/>
+              </a:spcBef>
+              <a:buNone/>
+            </a:pPr>
+            <a:endParaRPr lang="en-US" dirty="0">
+              <a:latin typeface="Courier"/>
+            </a:endParaRPr>
+          </a:p>
+          <a:p>
+            <a:pPr marL="0" indent="0">
+              <a:spcBef>
+                <a:spcPts val="0"/>
+              </a:spcBef>
+              <a:buNone/>
+            </a:pPr>
+            <a:r>
+              <a:rPr lang="en-US" dirty="0">
+                <a:latin typeface="Courier"/>
+              </a:rPr>
+              <a:t>#Model fit</a:t>
+            </a:r>
+          </a:p>
+          <a:p>
+            <a:pPr marL="0" indent="0">
+              <a:spcBef>
+                <a:spcPts val="0"/>
+              </a:spcBef>
+              <a:buNone/>
+            </a:pPr>
+            <a:r>
+              <a:rPr lang="en-US" dirty="0" err="1">
+                <a:latin typeface="Courier"/>
+              </a:rPr>
+              <a:t>model.fit</a:t>
+            </a:r>
+            <a:r>
+              <a:rPr lang="en-US" dirty="0">
+                <a:latin typeface="Courier"/>
+              </a:rPr>
+              <a:t>(X, y)</a:t>
+            </a:r>
+          </a:p>
+          <a:p>
+            <a:pPr marL="0" indent="0">
+              <a:spcBef>
+                <a:spcPts val="0"/>
+              </a:spcBef>
+              <a:buNone/>
+            </a:pPr>
+            <a:r>
+              <a:rPr lang="en-US" dirty="0" err="1">
+                <a:latin typeface="Courier"/>
+              </a:rPr>
+              <a:t>model.predict</a:t>
+            </a:r>
+            <a:r>
+              <a:rPr lang="en-US" dirty="0">
+                <a:latin typeface="Courier"/>
+              </a:rPr>
+              <a:t>(</a:t>
+            </a:r>
+            <a:r>
+              <a:rPr lang="en-US" dirty="0" err="1">
+                <a:latin typeface="Courier"/>
+              </a:rPr>
+              <a:t>X_new</a:t>
+            </a:r>
+            <a:r>
+              <a:rPr lang="en-US" dirty="0">
+                <a:latin typeface="Courier"/>
+              </a:rPr>
+              <a:t>)</a:t>
+            </a:r>
+          </a:p>
+          <a:p>
+            <a:pPr marL="0" indent="0">
+              <a:spcBef>
+                <a:spcPts val="0"/>
+              </a:spcBef>
+              <a:buNone/>
+            </a:pPr>
+            <a:br>
+              <a:rPr lang="en-US" dirty="0">
+                <a:latin typeface="Courier"/>
+              </a:rPr>
+            </a:br>
+            <a:r>
+              <a:rPr lang="en-US" dirty="0">
+                <a:latin typeface="Courier"/>
+              </a:rPr>
+              <a:t>#Model learned parameters:</a:t>
+            </a:r>
+          </a:p>
+          <a:p>
+            <a:pPr marL="0" indent="0">
+              <a:spcBef>
+                <a:spcPts val="0"/>
+              </a:spcBef>
+              <a:buNone/>
+            </a:pPr>
+            <a:r>
+              <a:rPr lang="en-US" dirty="0">
+                <a:latin typeface="Courier"/>
+              </a:rPr>
+              <a:t>coefficients = </a:t>
+            </a:r>
+            <a:r>
+              <a:rPr lang="en-US" dirty="0" err="1">
+                <a:latin typeface="Courier"/>
+              </a:rPr>
+              <a:t>model.coef</a:t>
+            </a:r>
+            <a:r>
+              <a:rPr lang="en-US" dirty="0">
+                <a:latin typeface="Courier"/>
+              </a:rPr>
+              <a:t>_</a:t>
+            </a:r>
+          </a:p>
+        </p:txBody>
+      </p:sp>
+    </p:spTree>
+    <p:extLst>
+      <p:ext uri="{BB962C8B-B14F-4D97-AF65-F5344CB8AC3E}">
+        <p14:creationId xmlns:p14="http://schemas.microsoft.com/office/powerpoint/2010/main" val="2984183878"/>
+      </p:ext>
+    </p:extLst>
+  </p:cSld>
+  <p:clrMapOvr>
+    <a:masterClrMapping/>
+  </p:clrMapOvr>
+</p:sld>
+</file>
+
+<file path=ppt/slides/slide5.xml><?xml version="1.0" encoding="utf-8"?>
+<p:sld xmlns:a="http://schemas.openxmlformats.org/drawingml/2006/main" xmlns:r="http://schemas.openxmlformats.org/officeDocument/2006/relationships" xmlns:p="http://schemas.openxmlformats.org/presentationml/2006/main" show="0">
+  <p:cSld>
+    <p:spTree>
+      <p:nvGrpSpPr>
+        <p:cNvPr id="1" name=""/>
+        <p:cNvGrpSpPr/>
+        <p:nvPr/>
+      </p:nvGrpSpPr>
+      <p:grpSpPr>
+        <a:xfrm>
+          <a:off x="0" y="0"/>
+          <a:ext cx="0" cy="0"/>
+          <a:chOff x="0" y="0"/>
+          <a:chExt cx="0" cy="0"/>
+        </a:xfrm>
+      </p:grpSpPr>
+      <p:sp>
+        <p:nvSpPr>
+          <p:cNvPr id="636" name="Scikit-Learn Design"/>
+          <p:cNvSpPr txBox="1">
+            <a:spLocks noGrp="1"/>
+          </p:cNvSpPr>
+          <p:nvPr>
+            <p:ph type="title"/>
+          </p:nvPr>
+        </p:nvSpPr>
+        <p:spPr>
+          <a:xfrm>
+            <a:off x="682528" y="832919"/>
+            <a:ext cx="10691265" cy="1307592"/>
+          </a:xfrm>
+          <a:prstGeom prst="rect">
+            <a:avLst/>
+          </a:prstGeom>
+        </p:spPr>
+        <p:txBody>
+          <a:bodyPr/>
+          <a:lstStyle/>
+          <a:p>
+            <a:r>
+              <a:rPr lang="en-US"/>
+              <a:t>Two conventions worth knowing</a:t>
+            </a:r>
+            <a:endParaRPr dirty="0"/>
+          </a:p>
+        </p:txBody>
+      </p:sp>
+      <p:sp>
+        <p:nvSpPr>
+          <p:cNvPr id="637" name="Consistency:   * All objects share a consistent and sensible interface…"/>
+          <p:cNvSpPr txBox="1">
+            <a:spLocks noGrp="1"/>
+          </p:cNvSpPr>
+          <p:nvPr>
+            <p:ph type="body" idx="1"/>
+          </p:nvPr>
+        </p:nvSpPr>
+        <p:spPr>
+          <a:xfrm>
+            <a:off x="2015133" y="1391768"/>
+            <a:ext cx="8161734" cy="4975099"/>
+          </a:xfrm>
+          <a:prstGeom prst="rect">
+            <a:avLst/>
+          </a:prstGeom>
+        </p:spPr>
+        <p:txBody>
+          <a:bodyPr>
+            <a:normAutofit/>
+          </a:bodyPr>
+          <a:lstStyle/>
+          <a:p>
+            <a:pPr marL="0" indent="0" defTabSz="161792">
+              <a:spcBef>
+                <a:spcPts val="700"/>
+              </a:spcBef>
+              <a:buNone/>
+              <a:defRPr sz="1900"/>
+            </a:pPr>
+            <a:r>
+              <a:rPr lang="en-US" sz="1900" b="1" dirty="0">
+                <a:latin typeface="Graphik"/>
+                <a:ea typeface="Graphik"/>
+                <a:cs typeface="Graphik"/>
+                <a:sym typeface="Graphik"/>
+              </a:rPr>
+              <a:t>Inspection</a:t>
+            </a:r>
+            <a:r>
+              <a:rPr lang="en-US" sz="1900" dirty="0"/>
+              <a:t>:</a:t>
+            </a:r>
+          </a:p>
+          <a:p>
+            <a:pPr marL="357188" indent="-203143" defTabSz="161792">
+              <a:spcBef>
+                <a:spcPts val="300"/>
+              </a:spcBef>
+              <a:defRPr sz="1900"/>
+            </a:pPr>
+            <a:r>
+              <a:rPr lang="en-US" sz="1900" dirty="0"/>
+              <a:t>Hyperparameters and learned parameters are plain attributes</a:t>
+            </a:r>
+          </a:p>
+          <a:p>
+            <a:pPr marL="357188" indent="-203143" defTabSz="161792">
+              <a:spcBef>
+                <a:spcPts val="300"/>
+              </a:spcBef>
+              <a:defRPr sz="1900"/>
+            </a:pPr>
+            <a:r>
+              <a:rPr lang="en-US" sz="1900" dirty="0"/>
+              <a:t>Learned parameters end in an underscore</a:t>
+            </a:r>
+          </a:p>
+          <a:p>
+            <a:pPr marL="0" indent="0" defTabSz="161792">
+              <a:spcBef>
+                <a:spcPts val="700"/>
+              </a:spcBef>
+              <a:buNone/>
+              <a:defRPr sz="1900"/>
+            </a:pPr>
+            <a:r>
+              <a:rPr lang="en-US" sz="1900" b="1" dirty="0">
+                <a:latin typeface="Graphik"/>
+                <a:ea typeface="Graphik"/>
+                <a:cs typeface="Graphik"/>
+                <a:sym typeface="Graphik"/>
+              </a:rPr>
+              <a:t>Sensible defaults</a:t>
+            </a:r>
+            <a:r>
+              <a:rPr lang="en-US" sz="1900" dirty="0"/>
+              <a:t>:</a:t>
+            </a:r>
+          </a:p>
+          <a:p>
+            <a:pPr marL="357188" indent="-203143" defTabSz="161792">
+              <a:spcBef>
+                <a:spcPts val="300"/>
+              </a:spcBef>
+              <a:defRPr sz="1900"/>
+            </a:pPr>
+            <a:r>
+              <a:rPr lang="en-US" sz="1900" dirty="0"/>
+              <a:t>Most parameters come with reasonable defaults</a:t>
+            </a:r>
+            <a:endParaRPr lang="en-US" dirty="0"/>
+          </a:p>
+        </p:txBody>
+      </p:sp>
+    </p:spTree>
+  </p:cSld>
+  <p:clrMapOvr>
+    <a:masterClrMapping/>
+  </p:clrMapOvr>
+  <p:transition spd="med"/>
+</p:sld>
+</file>
+
+<file path=ppt/slides/slide6.xml><?xml version="1.0" encoding="utf-8"?>
+<p:sld xmlns:a="http://schemas.openxmlformats.org/drawingml/2006/main" xmlns:r="http://schemas.openxmlformats.org/officeDocument/2006/relationships" xmlns:p="http://schemas.openxmlformats.org/presentationml/2006/main">
+  <p:cSld>
+    <p:spTree>
+      <p:nvGrpSpPr>
+        <p:cNvPr id="1" name=""/>
+        <p:cNvGrpSpPr/>
+        <p:nvPr/>
+      </p:nvGrpSpPr>
+      <p:grpSpPr>
+        <a:xfrm>
+          <a:off x="0" y="0"/>
+          <a:ext cx="0" cy="0"/>
+          <a:chOff x="0" y="0"/>
+          <a:chExt cx="0" cy="0"/>
+        </a:xfrm>
+      </p:grpSpPr>
+      <p:sp>
+        <p:nvSpPr>
           <p:cNvPr id="639" name="Scikit-Learn Design: Consistency"/>
           <p:cNvSpPr txBox="1">
             <a:spLocks noGrp="1"/>
@@ -7782,9 +8592,10 @@
           <a:lstStyle/>
           <a:p>
             <a:r>
-              <a:rPr dirty="0"/>
-              <a:t>Scikit-Learn Design: Consistency</a:t>
-            </a:r>
+              <a:rPr lang="en-US" dirty="0"/>
+              <a:t>Estimators</a:t>
+            </a:r>
+            <a:endParaRPr dirty="0"/>
           </a:p>
         </p:txBody>
       </p:sp>
@@ -7839,7 +8650,7 @@
             </a:pPr>
             <a:r>
               <a:rPr lang="en-US" sz="2000" dirty="0"/>
-              <a:t>Any object that can estimate some parameter based on a dataset</a:t>
+              <a:t>Any object that can estimate a parameter based on a dataset</a:t>
             </a:r>
           </a:p>
           <a:p>
@@ -7862,6 +8673,33 @@
             <a:r>
               <a:rPr lang="en-US" sz="2000" dirty="0"/>
               <a:t>method performs the estimation </a:t>
+            </a:r>
+          </a:p>
+          <a:p>
+            <a:pPr marL="0" indent="-256289" defTabSz="160014">
+              <a:defRPr sz="2520"/>
+            </a:pPr>
+            <a:r>
+              <a:rPr lang="en-US" sz="2200" b="1" dirty="0"/>
+              <a:t>Two Forms:</a:t>
+            </a:r>
+          </a:p>
+          <a:p>
+            <a:pPr marL="457200" lvl="1" indent="-256289" defTabSz="160014">
+              <a:defRPr sz="2520"/>
+            </a:pPr>
+            <a:r>
+              <a:rPr lang="en-US" sz="2000" dirty="0"/>
+              <a:t>Transformer</a:t>
+            </a:r>
+          </a:p>
+          <a:p>
+            <a:pPr marL="457200" lvl="1" indent="-256289" defTabSz="160014">
+              <a:defRPr sz="2520"/>
+            </a:pPr>
+            <a:r>
+              <a:rPr lang="en-US" sz="2000" dirty="0"/>
+              <a:t>Predictor</a:t>
             </a:r>
           </a:p>
           <a:p>
@@ -7887,7 +8725,7 @@
 </p:sld>
 </file>
 
-<file path=ppt/slides/slide5.xml><?xml version="1.0" encoding="utf-8"?>
+<file path=ppt/slides/slide7.xml><?xml version="1.0" encoding="utf-8"?>
 <p:sld xmlns:a="http://schemas.openxmlformats.org/drawingml/2006/main" xmlns:r="http://schemas.openxmlformats.org/officeDocument/2006/relationships" xmlns:p="http://schemas.openxmlformats.org/presentationml/2006/main">
   <p:cSld>
     <p:bg>
@@ -8135,9 +8973,10 @@
               </a:lnSpc>
             </a:pPr>
             <a:r>
-              <a:rPr lang="en-US" sz="3300" dirty="0"/>
-              <a:t>Scikit-Learn Design</a:t>
-            </a:r>
+              <a:rPr lang="en-US" sz="3300"/>
+              <a:t>Transformers</a:t>
+            </a:r>
+            <a:endParaRPr lang="en-US" sz="3300" dirty="0"/>
           </a:p>
         </p:txBody>
       </p:sp>
@@ -8376,7 +9215,7 @@
 </p:sld>
 </file>
 
-<file path=ppt/slides/slide6.xml><?xml version="1.0" encoding="utf-8"?>
+<file path=ppt/slides/slide8.xml><?xml version="1.0" encoding="utf-8"?>
 <p:sld xmlns:a="http://schemas.openxmlformats.org/drawingml/2006/main" xmlns:r="http://schemas.openxmlformats.org/officeDocument/2006/relationships" xmlns:p="http://schemas.openxmlformats.org/presentationml/2006/main">
   <p:cSld>
     <p:bg>
@@ -8624,9 +9463,10 @@
               </a:lnSpc>
             </a:pPr>
             <a:r>
-              <a:rPr lang="en-US" sz="3300" dirty="0"/>
-              <a:t>Scikit-Learn Design</a:t>
-            </a:r>
+              <a:rPr lang="en-US" sz="3300"/>
+              <a:t>Predictors</a:t>
+            </a:r>
+            <a:endParaRPr lang="en-US" sz="3300" dirty="0"/>
           </a:p>
         </p:txBody>
       </p:sp>
@@ -8843,7 +9683,7 @@
 </p:sld>
 </file>
 
-<file path=ppt/slides/slide7.xml><?xml version="1.0" encoding="utf-8"?>
+<file path=ppt/slides/slide9.xml><?xml version="1.0" encoding="utf-8"?>
 <p:sld xmlns:a="http://schemas.openxmlformats.org/drawingml/2006/main" xmlns:r="http://schemas.openxmlformats.org/officeDocument/2006/relationships" xmlns:p="http://schemas.openxmlformats.org/presentationml/2006/main">
   <p:cSld>
     <p:spTree>
@@ -8862,391 +9702,6 @@
       </p:grpSpPr>
       <p:sp>
         <p:nvSpPr>
-          <p:cNvPr id="2" name="Title 1">
-            <a:extLst>
-              <a:ext uri="{FF2B5EF4-FFF2-40B4-BE49-F238E27FC236}">
-                <a16:creationId xmlns:a16="http://schemas.microsoft.com/office/drawing/2014/main" id="{0EB25123-03AC-49EB-EA6D-74D26E76AC6F}"/>
-              </a:ext>
-            </a:extLst>
-          </p:cNvPr>
-          <p:cNvSpPr>
-            <a:spLocks noGrp="1"/>
-          </p:cNvSpPr>
-          <p:nvPr>
-            <p:ph type="title"/>
-          </p:nvPr>
-        </p:nvSpPr>
-        <p:spPr/>
-        <p:txBody>
-          <a:bodyPr/>
-          <a:lstStyle/>
-          <a:p>
-            <a:r>
-              <a:rPr lang="en-US" dirty="0"/>
-              <a:t>Object-oriented modeling</a:t>
-            </a:r>
-          </a:p>
-        </p:txBody>
-      </p:sp>
-      <p:sp>
-        <p:nvSpPr>
-          <p:cNvPr id="3" name="Content Placeholder 2">
-            <a:extLst>
-              <a:ext uri="{FF2B5EF4-FFF2-40B4-BE49-F238E27FC236}">
-                <a16:creationId xmlns:a16="http://schemas.microsoft.com/office/drawing/2014/main" id="{DC147735-00F0-8EBC-5C89-AC1921633E0E}"/>
-              </a:ext>
-            </a:extLst>
-          </p:cNvPr>
-          <p:cNvSpPr>
-            <a:spLocks noGrp="1"/>
-          </p:cNvSpPr>
-          <p:nvPr>
-            <p:ph sz="half" idx="1"/>
-          </p:nvPr>
-        </p:nvSpPr>
-        <p:spPr/>
-        <p:txBody>
-          <a:bodyPr>
-            <a:normAutofit fontScale="92500" lnSpcReduction="10000"/>
-          </a:bodyPr>
-          <a:lstStyle/>
-          <a:p>
-            <a:r>
-              <a:rPr lang="en-US" dirty="0"/>
-              <a:t>A model is an </a:t>
-            </a:r>
-            <a:r>
-              <a:rPr lang="en-US" b="1" dirty="0"/>
-              <a:t>object</a:t>
-            </a:r>
-            <a:r>
-              <a:rPr lang="en-US" dirty="0"/>
-              <a:t>:</a:t>
-            </a:r>
-          </a:p>
-          <a:p>
-            <a:pPr lvl="1"/>
-            <a:r>
-              <a:rPr lang="en-US" dirty="0"/>
-              <a:t>It has </a:t>
-            </a:r>
-            <a:r>
-              <a:rPr lang="en-US" b="1" dirty="0"/>
-              <a:t>state</a:t>
-            </a:r>
-            <a:r>
-              <a:rPr lang="en-US" dirty="0"/>
-              <a:t> (learned parameters)</a:t>
-            </a:r>
-          </a:p>
-          <a:p>
-            <a:pPr lvl="1"/>
-            <a:r>
-              <a:rPr lang="en-US" dirty="0"/>
-              <a:t>It has </a:t>
-            </a:r>
-            <a:r>
-              <a:rPr lang="en-US" b="1" dirty="0"/>
-              <a:t>methods</a:t>
-            </a:r>
-            <a:r>
-              <a:rPr lang="en-US" dirty="0"/>
-              <a:t> (fit, predict)</a:t>
-            </a:r>
-          </a:p>
-          <a:p>
-            <a:r>
-              <a:rPr lang="en-US" dirty="0"/>
-              <a:t>This allows:</a:t>
-            </a:r>
-          </a:p>
-          <a:p>
-            <a:pPr lvl="1"/>
-            <a:r>
-              <a:rPr lang="en-US" dirty="0"/>
-              <a:t>Reuse</a:t>
-            </a:r>
-          </a:p>
-          <a:p>
-            <a:pPr lvl="1"/>
-            <a:r>
-              <a:rPr lang="en-US" dirty="0"/>
-              <a:t>Inspection</a:t>
-            </a:r>
-          </a:p>
-          <a:p>
-            <a:pPr lvl="1"/>
-            <a:r>
-              <a:rPr lang="en-US" dirty="0"/>
-              <a:t>Composition (pipelines)</a:t>
-            </a:r>
-          </a:p>
-        </p:txBody>
-      </p:sp>
-      <p:sp>
-        <p:nvSpPr>
-          <p:cNvPr id="4" name="Content Placeholder 3">
-            <a:extLst>
-              <a:ext uri="{FF2B5EF4-FFF2-40B4-BE49-F238E27FC236}">
-                <a16:creationId xmlns:a16="http://schemas.microsoft.com/office/drawing/2014/main" id="{03E0D369-A01D-2EA7-0939-76A1FE027A5F}"/>
-              </a:ext>
-            </a:extLst>
-          </p:cNvPr>
-          <p:cNvSpPr>
-            <a:spLocks noGrp="1"/>
-          </p:cNvSpPr>
-          <p:nvPr>
-            <p:ph sz="half" idx="2"/>
-          </p:nvPr>
-        </p:nvSpPr>
-        <p:spPr/>
-        <p:txBody>
-          <a:bodyPr>
-            <a:normAutofit fontScale="92500" lnSpcReduction="10000"/>
-          </a:bodyPr>
-          <a:lstStyle/>
-          <a:p>
-            <a:pPr marL="0" indent="0">
-              <a:spcBef>
-                <a:spcPts val="0"/>
-              </a:spcBef>
-              <a:buNone/>
-            </a:pPr>
-            <a:r>
-              <a:rPr lang="en-US" dirty="0">
-                <a:latin typeface="Courier"/>
-              </a:rPr>
-              <a:t>from </a:t>
-            </a:r>
-            <a:r>
-              <a:rPr lang="en-US" dirty="0" err="1">
-                <a:latin typeface="Courier"/>
-              </a:rPr>
-              <a:t>sklearn.linear_model</a:t>
-            </a:r>
-            <a:r>
-              <a:rPr lang="en-US" dirty="0">
-                <a:latin typeface="Courier"/>
-              </a:rPr>
-              <a:t> import </a:t>
-            </a:r>
-            <a:r>
-              <a:rPr lang="en-US" dirty="0" err="1">
-                <a:latin typeface="Courier"/>
-              </a:rPr>
-              <a:t>LinearRegression</a:t>
-            </a:r>
-            <a:endParaRPr lang="en-US" dirty="0">
-              <a:latin typeface="Courier"/>
-            </a:endParaRPr>
-          </a:p>
-          <a:p>
-            <a:pPr marL="0" indent="0">
-              <a:spcBef>
-                <a:spcPts val="0"/>
-              </a:spcBef>
-              <a:buNone/>
-            </a:pPr>
-            <a:endParaRPr lang="en-US" dirty="0">
-              <a:latin typeface="Courier"/>
-            </a:endParaRPr>
-          </a:p>
-          <a:p>
-            <a:pPr marL="0" indent="0">
-              <a:spcBef>
-                <a:spcPts val="0"/>
-              </a:spcBef>
-              <a:buNone/>
-            </a:pPr>
-            <a:r>
-              <a:rPr lang="en-US" dirty="0">
-                <a:latin typeface="Courier"/>
-              </a:rPr>
-              <a:t># Model instantiation</a:t>
-            </a:r>
-          </a:p>
-          <a:p>
-            <a:pPr marL="0" indent="0">
-              <a:spcBef>
-                <a:spcPts val="0"/>
-              </a:spcBef>
-              <a:buNone/>
-            </a:pPr>
-            <a:r>
-              <a:rPr lang="en-US" dirty="0">
-                <a:latin typeface="Courier"/>
-              </a:rPr>
-              <a:t>model = </a:t>
-            </a:r>
-            <a:r>
-              <a:rPr lang="en-US" dirty="0" err="1">
-                <a:latin typeface="Courier"/>
-              </a:rPr>
-              <a:t>LinearRegression</a:t>
-            </a:r>
-            <a:r>
-              <a:rPr lang="en-US" dirty="0">
-                <a:latin typeface="Courier"/>
-              </a:rPr>
-              <a:t>()</a:t>
-            </a:r>
-          </a:p>
-          <a:p>
-            <a:pPr marL="0" indent="0">
-              <a:spcBef>
-                <a:spcPts val="0"/>
-              </a:spcBef>
-              <a:buNone/>
-            </a:pPr>
-            <a:endParaRPr lang="en-US" dirty="0">
-              <a:latin typeface="Courier"/>
-            </a:endParaRPr>
-          </a:p>
-          <a:p>
-            <a:pPr marL="0" indent="0">
-              <a:spcBef>
-                <a:spcPts val="0"/>
-              </a:spcBef>
-              <a:buNone/>
-            </a:pPr>
-            <a:r>
-              <a:rPr lang="en-US" dirty="0">
-                <a:latin typeface="Courier"/>
-              </a:rPr>
-              <a:t>#Model fit</a:t>
-            </a:r>
-          </a:p>
-          <a:p>
-            <a:pPr marL="0" indent="0">
-              <a:spcBef>
-                <a:spcPts val="0"/>
-              </a:spcBef>
-              <a:buNone/>
-            </a:pPr>
-            <a:r>
-              <a:rPr lang="en-US" dirty="0" err="1">
-                <a:latin typeface="Courier"/>
-              </a:rPr>
-              <a:t>model.fit</a:t>
-            </a:r>
-            <a:r>
-              <a:rPr lang="en-US" dirty="0">
-                <a:latin typeface="Courier"/>
-              </a:rPr>
-              <a:t>(X, y)</a:t>
-            </a:r>
-          </a:p>
-          <a:p>
-            <a:pPr marL="0" indent="0">
-              <a:spcBef>
-                <a:spcPts val="0"/>
-              </a:spcBef>
-              <a:buNone/>
-            </a:pPr>
-            <a:r>
-              <a:rPr lang="en-US" dirty="0" err="1">
-                <a:latin typeface="Courier"/>
-              </a:rPr>
-              <a:t>model.predict</a:t>
-            </a:r>
-            <a:r>
-              <a:rPr lang="en-US" dirty="0">
-                <a:latin typeface="Courier"/>
-              </a:rPr>
-              <a:t>(</a:t>
-            </a:r>
-            <a:r>
-              <a:rPr lang="en-US" dirty="0" err="1">
-                <a:latin typeface="Courier"/>
-              </a:rPr>
-              <a:t>X_new</a:t>
-            </a:r>
-            <a:r>
-              <a:rPr lang="en-US" dirty="0">
-                <a:latin typeface="Courier"/>
-              </a:rPr>
-              <a:t>)</a:t>
-            </a:r>
-          </a:p>
-          <a:p>
-            <a:pPr marL="0" indent="0">
-              <a:spcBef>
-                <a:spcPts val="0"/>
-              </a:spcBef>
-              <a:buNone/>
-            </a:pPr>
-            <a:br>
-              <a:rPr lang="en-US" dirty="0">
-                <a:latin typeface="Courier"/>
-              </a:rPr>
-            </a:br>
-            <a:r>
-              <a:rPr lang="en-US" dirty="0">
-                <a:latin typeface="Courier"/>
-              </a:rPr>
-              <a:t>#Model learned parameters:</a:t>
-            </a:r>
-          </a:p>
-          <a:p>
-            <a:pPr marL="0" indent="0">
-              <a:spcBef>
-                <a:spcPts val="0"/>
-              </a:spcBef>
-              <a:buNone/>
-            </a:pPr>
-            <a:r>
-              <a:rPr lang="en-US" dirty="0">
-                <a:latin typeface="Courier"/>
-              </a:rPr>
-              <a:t>coefficients = </a:t>
-            </a:r>
-            <a:r>
-              <a:rPr lang="en-US" dirty="0" err="1">
-                <a:latin typeface="Courier"/>
-              </a:rPr>
-              <a:t>model.coef</a:t>
-            </a:r>
-            <a:r>
-              <a:rPr lang="en-US" dirty="0">
-                <a:latin typeface="Courier"/>
-              </a:rPr>
-              <a:t>_</a:t>
-            </a:r>
-          </a:p>
-        </p:txBody>
-      </p:sp>
-    </p:spTree>
-    <p:extLst>
-      <p:ext uri="{BB962C8B-B14F-4D97-AF65-F5344CB8AC3E}">
-        <p14:creationId xmlns:p14="http://schemas.microsoft.com/office/powerpoint/2010/main" val="2984183878"/>
-      </p:ext>
-    </p:extLst>
-  </p:cSld>
-  <p:clrMapOvr>
-    <a:masterClrMapping/>
-  </p:clrMapOvr>
-</p:sld>
-</file>
-
-<file path=ppt/slides/slide8.xml><?xml version="1.0" encoding="utf-8"?>
-<p:sld xmlns:a="http://schemas.openxmlformats.org/drawingml/2006/main" xmlns:r="http://schemas.openxmlformats.org/officeDocument/2006/relationships" xmlns:p="http://schemas.openxmlformats.org/presentationml/2006/main">
-  <p:cSld>
-    <p:spTree>
-      <p:nvGrpSpPr>
-        <p:cNvPr id="1" name=""/>
-        <p:cNvGrpSpPr/>
-        <p:nvPr/>
-      </p:nvGrpSpPr>
-      <p:grpSpPr>
-        <a:xfrm>
-          <a:off x="0" y="0"/>
-          <a:ext cx="0" cy="0"/>
-          <a:chOff x="0" y="0"/>
-          <a:chExt cx="0" cy="0"/>
-        </a:xfrm>
-      </p:grpSpPr>
-      <p:sp>
-        <p:nvSpPr>
           <p:cNvPr id="643" name="Simple Scikit-Learn Usage"/>
           <p:cNvSpPr txBox="1">
             <a:spLocks noGrp="1"/>
@@ -9265,6 +9720,7 @@
           <a:lstStyle/>
           <a:p>
             <a:r>
+              <a:rPr dirty="0"/>
               <a:t>Simple Scikit-Learn Usage</a:t>
             </a:r>
           </a:p>
@@ -9297,7 +9753,7 @@
               <a:buAutoNum type="arabicPeriod"/>
             </a:pPr>
             <a:r>
-              <a:rPr dirty="0"/>
+              <a:rPr lang="en-US"/>
               <a:t>Prepare the data into a feature matrix and a target vector</a:t>
             </a:r>
           </a:p>
@@ -9306,7 +9762,7 @@
               <a:buAutoNum type="arabicPeriod"/>
             </a:pPr>
             <a:r>
-              <a:rPr dirty="0"/>
+              <a:rPr lang="en-US"/>
               <a:t>Choose a model and import </a:t>
             </a:r>
             <a:r>
@@ -9314,11 +9770,11 @@
               <a:t>the </a:t>
             </a:r>
             <a:r>
-              <a:rPr dirty="0"/>
+              <a:rPr lang="en-US"/>
               <a:t>estimator </a:t>
             </a:r>
             <a:r>
-              <a:rPr b="1" i="1" dirty="0">
+              <a:rPr lang="en-US" b="1" i="1">
                 <a:solidFill>
                   <a:srgbClr val="009051"/>
                 </a:solidFill>
@@ -9330,7 +9786,7 @@
               <a:t>class</a:t>
             </a:r>
             <a:r>
-              <a:rPr dirty="0"/>
+              <a:rPr lang="en-US"/>
               <a:t> from Scikit-Learn</a:t>
             </a:r>
             <a:endParaRPr lang="en-US" dirty="0"/>
@@ -9340,11 +9796,11 @@
               <a:buAutoNum type="arabicPeriod"/>
             </a:pPr>
             <a:r>
-              <a:rPr dirty="0"/>
+              <a:rPr lang="en-US"/>
               <a:t>Instantiate the model class and choose </a:t>
             </a:r>
             <a:r>
-              <a:rPr b="1" i="1" dirty="0" err="1">
+              <a:rPr lang="en-US" b="1" i="1">
                 <a:solidFill>
                   <a:srgbClr val="FF7E79"/>
                 </a:solidFill>
@@ -9353,18 +9809,18 @@
                 <a:cs typeface="Graphik"/>
                 <a:sym typeface="Graphik"/>
               </a:rPr>
-              <a:t>hyperparamters</a:t>
-            </a:r>
-            <a:r>
-              <a:rPr dirty="0"/>
+              <a:t>hyperparameters</a:t>
+            </a:r>
+            <a:r>
+              <a:rPr lang="en-US"/>
               <a:t> </a:t>
             </a:r>
             <a:br>
-              <a:rPr dirty="0"/>
+              <a:rPr lang="en-US"/>
             </a:br>
             <a:r>
-              <a:rPr dirty="0"/>
-              <a:t>(not all models classes have hyperparameters) </a:t>
+              <a:rPr lang="en-US"/>
+              <a:t>(not all model classes have hyperparameters)</a:t>
             </a:r>
           </a:p>
           <a:p>
@@ -9372,11 +9828,11 @@
               <a:buAutoNum type="arabicPeriod"/>
             </a:pPr>
             <a:r>
-              <a:rPr dirty="0"/>
+              <a:rPr lang="en-US"/>
               <a:t>Fit the model by calling the </a:t>
             </a:r>
             <a:r>
-              <a:rPr dirty="0">
+              <a:rPr lang="en-US">
                 <a:latin typeface="Courier"/>
                 <a:ea typeface="Courier"/>
                 <a:cs typeface="Courier"/>
@@ -9385,7 +9841,7 @@
               <a:t>.fit()</a:t>
             </a:r>
             <a:r>
-              <a:rPr dirty="0"/>
+              <a:rPr lang="en-US"/>
               <a:t> method</a:t>
             </a:r>
           </a:p>
@@ -9394,11 +9850,11 @@
               <a:buAutoNum type="arabicPeriod"/>
             </a:pPr>
             <a:r>
-              <a:rPr dirty="0"/>
+              <a:rPr lang="en-US"/>
               <a:t>Apply the model with the </a:t>
             </a:r>
             <a:r>
-              <a:rPr dirty="0">
+              <a:rPr lang="en-US">
                 <a:latin typeface="Courier"/>
                 <a:ea typeface="Courier"/>
                 <a:cs typeface="Courier"/>
@@ -9407,11 +9863,11 @@
               <a:t>.predict()</a:t>
             </a:r>
             <a:r>
-              <a:rPr dirty="0"/>
+              <a:rPr lang="en-US"/>
               <a:t> or the </a:t>
             </a:r>
             <a:r>
-              <a:rPr dirty="0">
+              <a:rPr lang="en-US">
                 <a:latin typeface="Courier"/>
                 <a:ea typeface="Courier"/>
                 <a:cs typeface="Courier"/>
@@ -9420,9 +9876,10 @@
               <a:t>.transform() </a:t>
             </a:r>
             <a:r>
-              <a:rPr dirty="0"/>
+              <a:rPr lang="en-US"/>
               <a:t>method</a:t>
             </a:r>
+            <a:endParaRPr dirty="0"/>
           </a:p>
         </p:txBody>
       </p:sp>
@@ -9463,7 +9920,7 @@
               </a:defRPr>
             </a:pPr>
             <a:r>
-              <a:rPr sz="1477" i="1" dirty="0">
+              <a:rPr lang="en-US" sz="1477" i="1">
                 <a:solidFill>
                   <a:srgbClr val="FF7E79"/>
                 </a:solidFill>
@@ -9475,18 +9932,24 @@
               <a:t>Hyperparameters</a:t>
             </a:r>
             <a:r>
-              <a:rPr sz="1477" dirty="0"/>
+              <a:rPr lang="en-US" sz="1477"/>
               <a:t>:   </a:t>
             </a:r>
             <a:r>
-              <a:rPr sz="1477" i="1" dirty="0">
+              <a:rPr lang="en-US" sz="1477" i="1">
                 <a:latin typeface="Graphik"/>
                 <a:ea typeface="Graphik"/>
                 <a:cs typeface="Graphik"/>
                 <a:sym typeface="Graphik"/>
               </a:rPr>
-              <a:t>Also called tuning parameters are parameters of the learning algorithm and not the model.  That is, its value is used to control the learning process and is chosen by the modeler rather than learned from the data. </a:t>
-            </a:r>
+              <a:t>settings you choose before fitting; they control learning and are not learned from the data</a:t>
+            </a:r>
+            <a:endParaRPr sz="1477" i="1">
+              <a:latin typeface="Graphik"/>
+              <a:ea typeface="Graphik"/>
+              <a:cs typeface="Graphik"/>
+              <a:sym typeface="Graphik"/>
+            </a:endParaRPr>
           </a:p>
         </p:txBody>
       </p:sp>
@@ -9527,7 +9990,7 @@
               </a:defRPr>
             </a:pPr>
             <a:r>
-              <a:rPr sz="1477" i="1" dirty="0">
+              <a:rPr lang="en-US" sz="1477" i="1">
                 <a:solidFill>
                   <a:srgbClr val="009051"/>
                 </a:solidFill>
@@ -9539,19 +10002,11 @@
               <a:t>Class</a:t>
             </a:r>
             <a:r>
-              <a:rPr sz="1477" dirty="0"/>
-              <a:t>:   Scikit-Learn makes extensive use of </a:t>
-            </a:r>
-            <a:r>
-              <a:rPr lang="en-US" sz="1477" dirty="0"/>
-              <a:t>Python</a:t>
-            </a:r>
-            <a:r>
-              <a:rPr sz="1477" dirty="0"/>
-              <a:t> classes and object oriented programming principles</a:t>
-            </a:r>
-            <a:r>
-              <a:rPr sz="1477" i="1" dirty="0">
+              <a:rPr lang="en-US" sz="1477"/>
+              <a:t>:   Scikit-Learn is built on Python classes and object-oriented principles</a:t>
+            </a:r>
+            <a:r>
+              <a:rPr lang="en-US" sz="1477" i="1">
                 <a:latin typeface="Graphik"/>
                 <a:ea typeface="Graphik"/>
                 <a:cs typeface="Graphik"/>
@@ -9559,249 +10014,12 @@
               </a:rPr>
               <a:t> </a:t>
             </a:r>
-          </a:p>
-        </p:txBody>
-      </p:sp>
-    </p:spTree>
-  </p:cSld>
-  <p:clrMapOvr>
-    <a:masterClrMapping/>
-  </p:clrMapOvr>
-  <p:transition spd="med"/>
-</p:sld>
-</file>
-
-<file path=ppt/slides/slide9.xml><?xml version="1.0" encoding="utf-8"?>
-<p:sld xmlns:a="http://schemas.openxmlformats.org/drawingml/2006/main" xmlns:r="http://schemas.openxmlformats.org/officeDocument/2006/relationships" xmlns:p="http://schemas.openxmlformats.org/presentationml/2006/main">
-  <p:cSld>
-    <p:spTree>
-      <p:nvGrpSpPr>
-        <p:cNvPr id="1" name=""/>
-        <p:cNvGrpSpPr/>
-        <p:nvPr/>
-      </p:nvGrpSpPr>
-      <p:grpSpPr>
-        <a:xfrm>
-          <a:off x="0" y="0"/>
-          <a:ext cx="0" cy="0"/>
-          <a:chOff x="0" y="0"/>
-          <a:chExt cx="0" cy="0"/>
-        </a:xfrm>
-      </p:grpSpPr>
-      <p:sp>
-        <p:nvSpPr>
-          <p:cNvPr id="649" name="Preparing your data"/>
-          <p:cNvSpPr txBox="1">
-            <a:spLocks noGrp="1"/>
-          </p:cNvSpPr>
-          <p:nvPr>
-            <p:ph type="title"/>
-          </p:nvPr>
-        </p:nvSpPr>
-        <p:spPr>
-          <a:prstGeom prst="rect">
-            <a:avLst/>
-          </a:prstGeom>
-        </p:spPr>
-        <p:txBody>
-          <a:bodyPr/>
-          <a:lstStyle/>
-          <a:p>
-            <a:r>
-              <a:rPr dirty="0"/>
-              <a:t>Preparing your data</a:t>
-            </a:r>
-          </a:p>
-        </p:txBody>
-      </p:sp>
-      <p:sp>
-        <p:nvSpPr>
-          <p:cNvPr id="650" name="The data should be in tabular form…"/>
-          <p:cNvSpPr txBox="1">
-            <a:spLocks noGrp="1"/>
-          </p:cNvSpPr>
-          <p:nvPr>
-            <p:ph type="body" idx="1"/>
-          </p:nvPr>
-        </p:nvSpPr>
-        <p:spPr>
-          <a:xfrm>
-            <a:off x="700634" y="1714998"/>
-            <a:ext cx="10691265" cy="3739896"/>
-          </a:xfrm>
-          <a:prstGeom prst="rect">
-            <a:avLst/>
-          </a:prstGeom>
-        </p:spPr>
-        <p:txBody>
-          <a:bodyPr>
-            <a:normAutofit/>
-          </a:bodyPr>
-          <a:lstStyle/>
-          <a:p>
-            <a:r>
-              <a:rPr dirty="0"/>
-              <a:t>The data should be in tabular form </a:t>
-            </a:r>
-          </a:p>
-          <a:p>
-            <a:pPr lvl="2"/>
-            <a:r>
-              <a:rPr lang="en-US" sz="2000" dirty="0"/>
-              <a:t>G</a:t>
-            </a:r>
-            <a:r>
-              <a:rPr sz="2000" dirty="0"/>
-              <a:t>enerally</a:t>
-            </a:r>
-            <a:r>
-              <a:rPr lang="en-US" sz="2000" dirty="0"/>
-              <a:t>,</a:t>
-            </a:r>
-            <a:r>
-              <a:rPr sz="2000" dirty="0"/>
-              <a:t> </a:t>
-            </a:r>
-            <a:r>
-              <a:rPr lang="en-US" sz="2000" dirty="0" err="1"/>
-              <a:t>Numpy</a:t>
-            </a:r>
-            <a:r>
-              <a:rPr sz="2000" dirty="0"/>
-              <a:t> or </a:t>
-            </a:r>
-            <a:r>
-              <a:rPr lang="en-US" sz="2000" dirty="0"/>
-              <a:t>Pandas</a:t>
-            </a:r>
-            <a:r>
-              <a:rPr sz="2000" dirty="0"/>
-              <a:t> </a:t>
-            </a:r>
-            <a:r>
-              <a:rPr lang="en-US" sz="2000" dirty="0"/>
-              <a:t>objects</a:t>
-            </a:r>
-            <a:endParaRPr sz="2000" dirty="0"/>
-          </a:p>
-          <a:p>
-            <a:pPr lvl="2"/>
-            <a:r>
-              <a:rPr sz="2000" dirty="0"/>
-              <a:t>The rows should be the observations or samples</a:t>
-            </a:r>
-          </a:p>
-          <a:p>
-            <a:r>
-              <a:rPr dirty="0"/>
-              <a:t>The feature matrix (X) should be a </a:t>
-            </a:r>
-            <a:r>
-              <a:rPr dirty="0">
-                <a:solidFill>
-                  <a:srgbClr val="FF7E79"/>
-                </a:solidFill>
-              </a:rPr>
-              <a:t>2D </a:t>
-            </a:r>
-            <a:r>
-              <a:rPr lang="en-US" dirty="0" err="1"/>
-              <a:t>Numpy</a:t>
-            </a:r>
-            <a:r>
-              <a:rPr dirty="0"/>
-              <a:t> array or a </a:t>
-            </a:r>
-            <a:r>
-              <a:rPr lang="en-US" dirty="0"/>
-              <a:t>Pandas</a:t>
-            </a:r>
-            <a:r>
-              <a:rPr dirty="0"/>
-              <a:t> </a:t>
-            </a:r>
-            <a:r>
-              <a:rPr dirty="0" err="1">
-                <a:solidFill>
-                  <a:srgbClr val="FF7E79"/>
-                </a:solidFill>
-              </a:rPr>
-              <a:t>DataFrame</a:t>
-            </a:r>
-            <a:r>
-              <a:rPr dirty="0"/>
-              <a:t> </a:t>
-            </a:r>
-          </a:p>
-          <a:p>
-            <a:pPr lvl="2"/>
-            <a:r>
-              <a:rPr sz="2000" dirty="0"/>
-              <a:t>This applies even when there is only 1 feature</a:t>
-            </a:r>
-            <a:endParaRPr lang="en-US" sz="2000" dirty="0"/>
-          </a:p>
-          <a:p>
-            <a:pPr lvl="2"/>
-            <a:r>
-              <a:rPr lang="en-US" sz="2000" b="1" dirty="0"/>
-              <a:t>Note</a:t>
-            </a:r>
-            <a:r>
-              <a:rPr lang="en-US" sz="2000" dirty="0"/>
-              <a:t>: if only one feature, it often must be reshaped using </a:t>
-            </a:r>
-            <a:r>
-              <a:rPr lang="en-US" sz="2000" dirty="0">
-                <a:latin typeface="Courier"/>
-              </a:rPr>
-              <a:t>.reshape(-1, 1)</a:t>
-            </a:r>
-            <a:endParaRPr sz="2000" dirty="0">
-              <a:latin typeface="Courier"/>
+            <a:endParaRPr sz="1477" i="1">
+              <a:latin typeface="Graphik"/>
+              <a:ea typeface="Graphik"/>
+              <a:cs typeface="Graphik"/>
+              <a:sym typeface="Graphik"/>
             </a:endParaRPr>
-          </a:p>
-          <a:p>
-            <a:r>
-              <a:rPr dirty="0"/>
-              <a:t>The target (Y) should be a </a:t>
-            </a:r>
-            <a:r>
-              <a:rPr dirty="0">
-                <a:solidFill>
-                  <a:srgbClr val="FF7E79"/>
-                </a:solidFill>
-              </a:rPr>
-              <a:t>1D</a:t>
-            </a:r>
-            <a:r>
-              <a:rPr dirty="0"/>
-              <a:t> </a:t>
-            </a:r>
-            <a:r>
-              <a:rPr lang="en-US" dirty="0" err="1"/>
-              <a:t>Numpy</a:t>
-            </a:r>
-            <a:r>
-              <a:rPr dirty="0"/>
-              <a:t> array or a </a:t>
-            </a:r>
-            <a:r>
-              <a:rPr lang="en-US" dirty="0"/>
-              <a:t>Pandas</a:t>
-            </a:r>
-            <a:r>
-              <a:rPr dirty="0"/>
-              <a:t> </a:t>
-            </a:r>
-            <a:r>
-              <a:rPr dirty="0">
-                <a:solidFill>
-                  <a:srgbClr val="FF7E79"/>
-                </a:solidFill>
-              </a:rPr>
-              <a:t>Series</a:t>
-            </a:r>
           </a:p>
         </p:txBody>
       </p:sp>

</xml_diff>

<commit_message>
post class slide update
</commit_message>
<xml_diff>
--- a/slides/03-intro-to-sklearn.pptx
+++ b/slides/03-intro-to-sklearn.pptx
@@ -213,7 +213,7 @@
           <a:p>
             <a:fld id="{A5320152-7289-42ED-97D3-BBB411F9F8C0}" type="datetimeFigureOut">
               <a:rPr lang="en-US" smtClean="0"/>
-              <a:t>9/9/2026</a:t>
+              <a:t>9/10/2026</a:t>
             </a:fld>
             <a:endParaRPr lang="en-US"/>
           </a:p>
@@ -633,7 +633,7 @@
           <a:p>
             <a:fld id="{D1D1EADE-8E88-4C7C-8AC5-FB148DE4940E}" type="datetime1">
               <a:rPr lang="en-US" smtClean="0"/>
-              <a:t>9/9/2026</a:t>
+              <a:t>9/10/2026</a:t>
             </a:fld>
             <a:endParaRPr lang="en-US"/>
           </a:p>
@@ -833,7 +833,7 @@
           <a:p>
             <a:fld id="{EC3C8B9C-477D-492A-96AD-1FC2CC997A73}" type="datetime1">
               <a:rPr lang="en-US" smtClean="0"/>
-              <a:t>9/9/2026</a:t>
+              <a:t>9/10/2026</a:t>
             </a:fld>
             <a:endParaRPr lang="en-US"/>
           </a:p>
@@ -1043,7 +1043,7 @@
           <a:p>
             <a:fld id="{42D3AED5-E26D-4E29-B1B3-7847B6779594}" type="datetime1">
               <a:rPr lang="en-US" smtClean="0"/>
-              <a:t>9/9/2026</a:t>
+              <a:t>9/10/2026</a:t>
             </a:fld>
             <a:endParaRPr lang="en-US"/>
           </a:p>
@@ -1538,7 +1538,7 @@
           <a:p>
             <a:fld id="{157B6794-849E-4626-908B-D15793550EFB}" type="datetime1">
               <a:rPr lang="en-US" smtClean="0"/>
-              <a:t>9/9/2026</a:t>
+              <a:t>9/10/2026</a:t>
             </a:fld>
             <a:endParaRPr lang="en-US"/>
           </a:p>
@@ -1814,7 +1814,7 @@
           <a:p>
             <a:fld id="{63DB64E7-5594-42A3-ADBF-E95A7ACEAD64}" type="datetime1">
               <a:rPr lang="en-US" smtClean="0"/>
-              <a:t>9/9/2026</a:t>
+              <a:t>9/10/2026</a:t>
             </a:fld>
             <a:endParaRPr lang="en-US"/>
           </a:p>
@@ -2087,7 +2087,7 @@
           <a:p>
             <a:fld id="{18462B0B-D248-4FFB-8695-AD7FA4B1284A}" type="datetime1">
               <a:rPr lang="en-US" smtClean="0"/>
-              <a:t>9/9/2026</a:t>
+              <a:t>9/10/2026</a:t>
             </a:fld>
             <a:endParaRPr lang="en-US"/>
           </a:p>
@@ -2510,7 +2510,7 @@
           <a:p>
             <a:fld id="{D0378EFB-9159-4510-B73F-4F0409ADE937}" type="datetime1">
               <a:rPr lang="en-US" smtClean="0"/>
-              <a:t>9/9/2026</a:t>
+              <a:t>9/10/2026</a:t>
             </a:fld>
             <a:endParaRPr lang="en-US"/>
           </a:p>
@@ -2652,7 +2652,7 @@
           <a:p>
             <a:fld id="{89BC9412-2452-4BED-A324-9D8C115361AD}" type="datetime1">
               <a:rPr lang="en-US" smtClean="0"/>
-              <a:t>9/9/2026</a:t>
+              <a:t>9/10/2026</a:t>
             </a:fld>
             <a:endParaRPr lang="en-US"/>
           </a:p>
@@ -2765,7 +2765,7 @@
           <a:p>
             <a:fld id="{F5318F62-D251-40E8-A23C-F4CFE9FEAB41}" type="datetime1">
               <a:rPr lang="en-US" smtClean="0"/>
-              <a:t>9/9/2026</a:t>
+              <a:t>9/10/2026</a:t>
             </a:fld>
             <a:endParaRPr lang="en-US"/>
           </a:p>
@@ -3078,7 +3078,7 @@
           <a:p>
             <a:fld id="{44F76144-149E-4874-93A5-554A0357CF82}" type="datetime1">
               <a:rPr lang="en-US" smtClean="0"/>
-              <a:t>9/9/2026</a:t>
+              <a:t>9/10/2026</a:t>
             </a:fld>
             <a:endParaRPr lang="en-US"/>
           </a:p>
@@ -3371,7 +3371,7 @@
           <a:p>
             <a:fld id="{50BA65D8-0540-4835-AE5C-25D29DBA01BE}" type="datetime1">
               <a:rPr lang="en-US" smtClean="0"/>
-              <a:t>9/9/2026</a:t>
+              <a:t>9/10/2026</a:t>
             </a:fld>
             <a:endParaRPr lang="en-US"/>
           </a:p>
@@ -3613,7 +3613,7 @@
           <a:p>
             <a:fld id="{E31BA835-12AC-4E8F-955A-EA3F4DE2791F}" type="datetime1">
               <a:rPr lang="en-US" smtClean="0"/>
-              <a:t>9/9/2026</a:t>
+              <a:t>9/10/2026</a:t>
             </a:fld>
             <a:endParaRPr lang="en-US"/>
           </a:p>
@@ -4815,7 +4815,7 @@
         <p:spPr>
           <a:xfrm>
             <a:off x="493485" y="2075974"/>
-            <a:ext cx="14615886" cy="4682051"/>
+            <a:ext cx="14615886" cy="4402487"/>
           </a:xfrm>
           <a:prstGeom prst="rect">
             <a:avLst/>
@@ -4830,7 +4830,7 @@
           <a:p>
             <a:pPr>
               <a:lnSpc>
-                <a:spcPts val="1425"/>
+                <a:spcPts val="1250"/>
               </a:lnSpc>
               <a:spcAft>
                 <a:spcPts val="200"/>
@@ -4838,7 +4838,7 @@
               <a:buNone/>
             </a:pPr>
             <a:r>
-              <a:rPr lang="en-US" sz="1700" b="0" dirty="0">
+              <a:rPr lang="en-US" sz="1450" b="0">
                 <a:solidFill>
                   <a:srgbClr val="C586C0"/>
                 </a:solidFill>
@@ -4848,60 +4848,40 @@
               <a:t>import</a:t>
             </a:r>
             <a:r>
-              <a:rPr lang="en-US" sz="1700" b="0" dirty="0">
+              <a:rPr lang="en-US" sz="1450" b="0">
                 <a:solidFill>
                   <a:srgbClr val="CCCCCC"/>
                 </a:solidFill>
                 <a:effectLst/>
                 <a:latin typeface="Courier"/>
               </a:rPr>
-              <a:t> </a:t>
-            </a:r>
-            <a:r>
-              <a:rPr lang="en-US" sz="1700" b="0" dirty="0" err="1">
-                <a:solidFill>
-                  <a:srgbClr val="CCCCCC"/>
+              <a:t> numpy </a:t>
+            </a:r>
+            <a:r>
+              <a:rPr lang="en-US" sz="1450" b="0">
+                <a:solidFill>
+                  <a:srgbClr val="C586C0"/>
                 </a:solidFill>
                 <a:effectLst/>
                 <a:latin typeface="Courier"/>
               </a:rPr>
-              <a:t>numpy</a:t>
-            </a:r>
-            <a:r>
-              <a:rPr lang="en-US" sz="1700" b="0" dirty="0">
+              <a:t>as</a:t>
+            </a:r>
+            <a:r>
+              <a:rPr lang="en-US" sz="1450" b="0">
                 <a:solidFill>
                   <a:srgbClr val="CCCCCC"/>
                 </a:solidFill>
                 <a:effectLst/>
                 <a:latin typeface="Courier"/>
               </a:rPr>
-              <a:t> </a:t>
-            </a:r>
-            <a:r>
-              <a:rPr lang="en-US" sz="1700" b="0" dirty="0">
-                <a:solidFill>
-                  <a:srgbClr val="C586C0"/>
-                </a:solidFill>
-                <a:effectLst/>
-                <a:latin typeface="Courier"/>
-              </a:rPr>
-              <a:t>as</a:t>
-            </a:r>
-            <a:r>
-              <a:rPr lang="en-US" sz="1700" b="0" dirty="0">
-                <a:solidFill>
-                  <a:srgbClr val="CCCCCC"/>
-                </a:solidFill>
-                <a:effectLst/>
-                <a:latin typeface="Courier"/>
-              </a:rPr>
               <a:t> np</a:t>
             </a:r>
           </a:p>
           <a:p>
             <a:pPr>
               <a:lnSpc>
-                <a:spcPts val="1425"/>
+                <a:spcPts val="1250"/>
               </a:lnSpc>
               <a:spcAft>
                 <a:spcPts val="200"/>
@@ -4909,7 +4889,7 @@
               <a:buNone/>
             </a:pPr>
             <a:r>
-              <a:rPr lang="en-US" sz="1700" b="0" dirty="0">
+              <a:rPr lang="en-US" sz="1450" b="0">
                 <a:solidFill>
                   <a:srgbClr val="C586C0"/>
                 </a:solidFill>
@@ -4919,66 +4899,97 @@
               <a:t>from</a:t>
             </a:r>
             <a:r>
-              <a:rPr lang="en-US" sz="1700" b="0" dirty="0">
+              <a:rPr lang="en-US" sz="1450" b="0">
                 <a:solidFill>
                   <a:srgbClr val="CCCCCC"/>
                 </a:solidFill>
                 <a:effectLst/>
                 <a:latin typeface="Courier"/>
               </a:rPr>
-              <a:t> </a:t>
-            </a:r>
-            <a:r>
-              <a:rPr lang="en-US" sz="1700" b="0" dirty="0" err="1">
-                <a:solidFill>
-                  <a:srgbClr val="CCCCCC"/>
+              <a:t> sklearn.linear_model </a:t>
+            </a:r>
+            <a:r>
+              <a:rPr lang="en-US" sz="1450" b="0">
+                <a:solidFill>
+                  <a:srgbClr val="C586C0"/>
                 </a:solidFill>
                 <a:effectLst/>
                 <a:latin typeface="Courier"/>
               </a:rPr>
-              <a:t>sklearn.linear_model</a:t>
-            </a:r>
-            <a:r>
-              <a:rPr lang="en-US" sz="1700" b="0" dirty="0">
+              <a:t>import</a:t>
+            </a:r>
+            <a:r>
+              <a:rPr lang="en-US" sz="1450" b="0">
                 <a:solidFill>
                   <a:srgbClr val="CCCCCC"/>
                 </a:solidFill>
                 <a:effectLst/>
                 <a:latin typeface="Courier"/>
               </a:rPr>
-              <a:t> </a:t>
-            </a:r>
-            <a:r>
-              <a:rPr lang="en-US" sz="1700" b="0" dirty="0">
+              <a:t> LinearRegression</a:t>
+            </a:r>
+          </a:p>
+          <a:p>
+            <a:pPr>
+              <a:lnSpc>
+                <a:spcPts val="1250"/>
+              </a:lnSpc>
+              <a:spcAft>
+                <a:spcPts val="200"/>
+              </a:spcAft>
+              <a:buNone/>
+            </a:pPr>
+            <a:r>
+              <a:rPr lang="en-US" sz="1450" b="0">
                 <a:solidFill>
                   <a:srgbClr val="C586C0"/>
                 </a:solidFill>
                 <a:effectLst/>
                 <a:latin typeface="Courier"/>
               </a:rPr>
-              <a:t>import</a:t>
-            </a:r>
-            <a:r>
-              <a:rPr lang="en-US" sz="1700" b="0" dirty="0">
+              <a:t>from</a:t>
+            </a:r>
+            <a:r>
+              <a:rPr lang="en-US" sz="1450" b="0">
                 <a:solidFill>
                   <a:srgbClr val="CCCCCC"/>
                 </a:solidFill>
                 <a:effectLst/>
                 <a:latin typeface="Courier"/>
               </a:rPr>
-              <a:t> </a:t>
-            </a:r>
-            <a:r>
-              <a:rPr lang="en-US" sz="1700" b="0" dirty="0" err="1">
-                <a:solidFill>
-                  <a:srgbClr val="CCCCCC"/>
+              <a:t> sklearn.model_selection </a:t>
+            </a:r>
+            <a:r>
+              <a:rPr lang="en-US" sz="1450" b="0">
+                <a:solidFill>
+                  <a:srgbClr val="C586C0"/>
                 </a:solidFill>
                 <a:effectLst/>
                 <a:latin typeface="Courier"/>
               </a:rPr>
-              <a:t>LinearRegression</a:t>
-            </a:r>
-            <a:endParaRPr lang="en-US" sz="1700" b="0" dirty="0">
+              <a:t>import</a:t>
+            </a:r>
+            <a:r>
+              <a:rPr lang="en-US" sz="1450" b="0">
+                <a:solidFill>
+                  <a:srgbClr val="CCCCCC"/>
+                </a:solidFill>
+                <a:effectLst/>
+                <a:latin typeface="Courier"/>
+              </a:rPr>
+              <a:t> </a:t>
+            </a:r>
+            <a:r>
+              <a:rPr lang="en-US" sz="1450" b="0">
+                <a:solidFill>
+                  <a:srgbClr val="DCDCAA"/>
+                </a:solidFill>
+                <a:effectLst/>
+                <a:latin typeface="Courier"/>
+              </a:rPr>
+              <a:t>train_test_split</a:t>
+            </a:r>
+            <a:endParaRPr lang="en-US" sz="1450" b="0">
               <a:solidFill>
                 <a:srgbClr val="CCCCCC"/>
               </a:solidFill>
@@ -4989,7 +5000,7 @@
           <a:p>
             <a:pPr>
               <a:lnSpc>
-                <a:spcPts val="1425"/>
+                <a:spcPts val="1250"/>
               </a:lnSpc>
               <a:spcAft>
                 <a:spcPts val="200"/>
@@ -4997,7 +5008,7 @@
               <a:buNone/>
             </a:pPr>
             <a:br>
-              <a:rPr lang="en-US" sz="1700" b="0" dirty="0">
+              <a:rPr lang="en-US" sz="1450" b="0">
                 <a:solidFill>
                   <a:srgbClr val="CCCCCC"/>
                 </a:solidFill>
@@ -5005,7 +5016,7 @@
                 <a:latin typeface="Courier"/>
               </a:rPr>
             </a:br>
-            <a:endParaRPr lang="en-US" sz="1700" b="0" dirty="0">
+            <a:endParaRPr lang="en-US" sz="1450" b="0">
               <a:solidFill>
                 <a:srgbClr val="CCCCCC"/>
               </a:solidFill>
@@ -5016,7 +5027,7 @@
           <a:p>
             <a:pPr>
               <a:lnSpc>
-                <a:spcPts val="1425"/>
+                <a:spcPts val="1250"/>
               </a:lnSpc>
               <a:spcAft>
                 <a:spcPts val="200"/>
@@ -5024,7 +5035,7 @@
               <a:buNone/>
             </a:pPr>
             <a:r>
-              <a:rPr lang="en-US" sz="1700" b="0" dirty="0">
+              <a:rPr lang="en-US" sz="1450" b="0">
                 <a:solidFill>
                   <a:srgbClr val="6A9955"/>
                 </a:solidFill>
@@ -5033,7 +5044,7 @@
               </a:rPr>
               <a:t># Create simple data</a:t>
             </a:r>
-            <a:endParaRPr lang="en-US" sz="1700" b="0" dirty="0">
+            <a:endParaRPr lang="en-US" sz="1450" b="0">
               <a:solidFill>
                 <a:srgbClr val="CCCCCC"/>
               </a:solidFill>
@@ -5044,7 +5055,7 @@
           <a:p>
             <a:pPr>
               <a:lnSpc>
-                <a:spcPts val="1425"/>
+                <a:spcPts val="1250"/>
               </a:lnSpc>
               <a:spcAft>
                 <a:spcPts val="200"/>
@@ -5052,7 +5063,7 @@
               <a:buNone/>
             </a:pPr>
             <a:r>
-              <a:rPr lang="en-US" sz="1700" b="0" dirty="0">
+              <a:rPr lang="en-US" sz="1450" b="0">
                 <a:solidFill>
                   <a:srgbClr val="CCCCCC"/>
                 </a:solidFill>
@@ -5062,7 +5073,7 @@
               <a:t>X </a:t>
             </a:r>
             <a:r>
-              <a:rPr lang="en-US" sz="1700" b="0" dirty="0">
+              <a:rPr lang="en-US" sz="1450" b="0">
                 <a:solidFill>
                   <a:srgbClr val="D4D4D4"/>
                 </a:solidFill>
@@ -5072,236 +5083,116 @@
               <a:t>=</a:t>
             </a:r>
             <a:r>
-              <a:rPr lang="en-US" sz="1700" b="0" dirty="0">
+              <a:rPr lang="en-US" sz="1450" b="0">
                 <a:solidFill>
                   <a:srgbClr val="CCCCCC"/>
                 </a:solidFill>
                 <a:effectLst/>
                 <a:latin typeface="Courier"/>
               </a:rPr>
-              <a:t> </a:t>
-            </a:r>
-            <a:r>
-              <a:rPr lang="en-US" sz="1700" b="0" dirty="0" err="1">
-                <a:solidFill>
-                  <a:srgbClr val="CCCCCC"/>
+              <a:t> np.arange(</a:t>
+            </a:r>
+            <a:r>
+              <a:rPr lang="en-US" sz="1450" b="0">
+                <a:solidFill>
+                  <a:srgbClr val="B5CEA8"/>
                 </a:solidFill>
                 <a:effectLst/>
                 <a:latin typeface="Courier"/>
               </a:rPr>
-              <a:t>np.array</a:t>
-            </a:r>
-            <a:r>
-              <a:rPr lang="en-US" sz="1700" b="0" dirty="0">
+              <a:t>1</a:t>
+            </a:r>
+            <a:r>
+              <a:rPr lang="en-US" sz="1450" b="0">
                 <a:solidFill>
                   <a:srgbClr val="CCCCCC"/>
                 </a:solidFill>
                 <a:effectLst/>
                 <a:latin typeface="Courier"/>
               </a:rPr>
-              <a:t>([</a:t>
-            </a:r>
-            <a:r>
-              <a:rPr lang="en-US" sz="1700" b="0" dirty="0">
+              <a:t>, </a:t>
+            </a:r>
+            <a:r>
+              <a:rPr lang="en-US" sz="1450" b="0">
                 <a:solidFill>
                   <a:srgbClr val="B5CEA8"/>
                 </a:solidFill>
                 <a:effectLst/>
                 <a:latin typeface="Courier"/>
               </a:rPr>
-              <a:t>1</a:t>
-            </a:r>
-            <a:r>
-              <a:rPr lang="en-US" sz="1700" b="0" dirty="0">
+              <a:t>21</a:t>
+            </a:r>
+            <a:r>
+              <a:rPr lang="en-US" sz="1450" b="0">
                 <a:solidFill>
                   <a:srgbClr val="CCCCCC"/>
                 </a:solidFill>
                 <a:effectLst/>
                 <a:latin typeface="Courier"/>
               </a:rPr>
-              <a:t>, </a:t>
-            </a:r>
-            <a:r>
-              <a:rPr lang="en-US" sz="1700" b="0" dirty="0">
-                <a:solidFill>
-                  <a:srgbClr val="B5CEA8"/>
+              <a:t>).reshape(</a:t>
+            </a:r>
+            <a:r>
+              <a:rPr lang="en-US" sz="1450" b="0">
+                <a:solidFill>
+                  <a:srgbClr val="D4D4D4"/>
                 </a:solidFill>
                 <a:effectLst/>
                 <a:latin typeface="Courier"/>
               </a:rPr>
-              <a:t>2</a:t>
-            </a:r>
-            <a:r>
-              <a:rPr lang="en-US" sz="1700" b="0" dirty="0">
-                <a:solidFill>
-                  <a:srgbClr val="CCCCCC"/>
+              <a:t>-</a:t>
+            </a:r>
+            <a:r>
+              <a:rPr lang="en-US" sz="1450" b="0">
+                <a:solidFill>
+                  <a:srgbClr val="B5CEA8"/>
                 </a:solidFill>
                 <a:effectLst/>
                 <a:latin typeface="Courier"/>
               </a:rPr>
-              <a:t>, </a:t>
-            </a:r>
-            <a:r>
-              <a:rPr lang="en-US" sz="1700" b="0" dirty="0">
-                <a:solidFill>
-                  <a:srgbClr val="B5CEA8"/>
+              <a:t>1</a:t>
+            </a:r>
+            <a:r>
+              <a:rPr lang="en-US" sz="1450" b="0">
+                <a:solidFill>
+                  <a:srgbClr val="CCCCCC"/>
                 </a:solidFill>
                 <a:effectLst/>
                 <a:latin typeface="Courier"/>
               </a:rPr>
-              <a:t>3</a:t>
-            </a:r>
-            <a:r>
-              <a:rPr lang="en-US" sz="1700" b="0" dirty="0">
-                <a:solidFill>
-                  <a:srgbClr val="CCCCCC"/>
+              <a:t>, </a:t>
+            </a:r>
+            <a:r>
+              <a:rPr lang="en-US" sz="1450" b="0">
+                <a:solidFill>
+                  <a:srgbClr val="B5CEA8"/>
                 </a:solidFill>
                 <a:effectLst/>
                 <a:latin typeface="Courier"/>
               </a:rPr>
-              <a:t>, </a:t>
-            </a:r>
-            <a:r>
-              <a:rPr lang="en-US" sz="1700" b="0" dirty="0">
-                <a:solidFill>
-                  <a:srgbClr val="B5CEA8"/>
+              <a:t>1</a:t>
+            </a:r>
+            <a:r>
+              <a:rPr lang="en-US" sz="1450" b="0">
+                <a:solidFill>
+                  <a:srgbClr val="CCCCCC"/>
                 </a:solidFill>
                 <a:effectLst/>
                 <a:latin typeface="Courier"/>
               </a:rPr>
-              <a:t>4</a:t>
-            </a:r>
-            <a:r>
-              <a:rPr lang="en-US" sz="1700" b="0" dirty="0">
-                <a:solidFill>
-                  <a:srgbClr val="CCCCCC"/>
+              <a:t>)   </a:t>
+            </a:r>
+            <a:r>
+              <a:rPr lang="en-US" sz="1450" b="0">
+                <a:solidFill>
+                  <a:srgbClr val="6A9955"/>
                 </a:solidFill>
                 <a:effectLst/>
                 <a:latin typeface="Courier"/>
               </a:rPr>
-              <a:t>, </a:t>
-            </a:r>
-            <a:r>
-              <a:rPr lang="en-US" sz="1700" b="0" dirty="0">
-                <a:solidFill>
-                  <a:srgbClr val="B5CEA8"/>
-                </a:solidFill>
-                <a:effectLst/>
-                <a:latin typeface="Courier"/>
-              </a:rPr>
-              <a:t>5</a:t>
-            </a:r>
-            <a:r>
-              <a:rPr lang="en-US" sz="1700" b="0" dirty="0">
-                <a:solidFill>
-                  <a:srgbClr val="CCCCCC"/>
-                </a:solidFill>
-                <a:effectLst/>
-                <a:latin typeface="Courier"/>
-              </a:rPr>
-              <a:t>]).reshape(</a:t>
-            </a:r>
-            <a:r>
-              <a:rPr lang="en-US" sz="1700" b="0" dirty="0">
-                <a:solidFill>
-                  <a:srgbClr val="D4D4D4"/>
-                </a:solidFill>
-                <a:effectLst/>
-                <a:latin typeface="Courier"/>
-              </a:rPr>
-              <a:t>-</a:t>
-            </a:r>
-            <a:r>
-              <a:rPr lang="en-US" sz="1700" b="0" dirty="0">
-                <a:solidFill>
-                  <a:srgbClr val="B5CEA8"/>
-                </a:solidFill>
-                <a:effectLst/>
-                <a:latin typeface="Courier"/>
-              </a:rPr>
-              <a:t>1</a:t>
-            </a:r>
-            <a:r>
-              <a:rPr lang="en-US" sz="1700" b="0" dirty="0">
-                <a:solidFill>
-                  <a:srgbClr val="CCCCCC"/>
-                </a:solidFill>
-                <a:effectLst/>
-                <a:latin typeface="Courier"/>
-              </a:rPr>
-              <a:t>, </a:t>
-            </a:r>
-            <a:r>
-              <a:rPr lang="en-US" sz="1700" b="0" dirty="0">
-                <a:solidFill>
-                  <a:srgbClr val="B5CEA8"/>
-                </a:solidFill>
-                <a:effectLst/>
-                <a:latin typeface="Courier"/>
-              </a:rPr>
-              <a:t>1</a:t>
-            </a:r>
-            <a:r>
-              <a:rPr lang="en-US" sz="1700" b="0" dirty="0">
-                <a:solidFill>
-                  <a:srgbClr val="CCCCCC"/>
-                </a:solidFill>
-                <a:effectLst/>
-                <a:latin typeface="Courier"/>
-              </a:rPr>
-              <a:t>)  </a:t>
-            </a:r>
-            <a:r>
-              <a:rPr lang="en-US" sz="1700" b="0" dirty="0">
-                <a:solidFill>
-                  <a:srgbClr val="6A9955"/>
-                </a:solidFill>
-                <a:effectLst/>
-                <a:latin typeface="Courier"/>
-              </a:rPr>
-              <a:t># feature matrix (</a:t>
-            </a:r>
-            <a:r>
-              <a:rPr lang="en-US" sz="1700" b="0" dirty="0" err="1">
-                <a:solidFill>
-                  <a:srgbClr val="6A9955"/>
-                </a:solidFill>
-                <a:effectLst/>
-                <a:latin typeface="Courier"/>
-              </a:rPr>
-              <a:t>n_samples</a:t>
-            </a:r>
-            <a:r>
-              <a:rPr lang="en-US" sz="1700" b="0" dirty="0">
-                <a:solidFill>
-                  <a:srgbClr val="6A9955"/>
-                </a:solidFill>
-                <a:effectLst/>
-                <a:latin typeface="Courier"/>
-              </a:rPr>
-              <a:t>, </a:t>
-            </a:r>
-            <a:r>
-              <a:rPr lang="en-US" sz="1700" b="0" dirty="0" err="1">
-                <a:solidFill>
-                  <a:srgbClr val="6A9955"/>
-                </a:solidFill>
-                <a:effectLst/>
-                <a:latin typeface="Courier"/>
-              </a:rPr>
-              <a:t>n_features</a:t>
-            </a:r>
-            <a:r>
-              <a:rPr lang="en-US" sz="1700" b="0" dirty="0">
-                <a:solidFill>
-                  <a:srgbClr val="6A9955"/>
-                </a:solidFill>
-                <a:effectLst/>
-                <a:latin typeface="Courier"/>
-              </a:rPr>
-              <a:t>)</a:t>
-            </a:r>
-            <a:endParaRPr lang="en-US" sz="1700" b="0" dirty="0">
+              <a:t># feature matrix (n_samples, n_features)</a:t>
+            </a:r>
+            <a:endParaRPr lang="en-US" sz="1450" b="0">
               <a:solidFill>
                 <a:srgbClr val="CCCCCC"/>
               </a:solidFill>
@@ -5312,7 +5203,7 @@
           <a:p>
             <a:pPr>
               <a:lnSpc>
-                <a:spcPts val="1425"/>
+                <a:spcPts val="1250"/>
               </a:lnSpc>
               <a:spcAft>
                 <a:spcPts val="200"/>
@@ -5320,7 +5211,7 @@
               <a:buNone/>
             </a:pPr>
             <a:r>
-              <a:rPr lang="en-US" sz="1700" b="0" dirty="0">
+              <a:rPr lang="en-US" sz="1450" b="0">
                 <a:solidFill>
                   <a:srgbClr val="CCCCCC"/>
                 </a:solidFill>
@@ -5330,7 +5221,7 @@
               <a:t>y </a:t>
             </a:r>
             <a:r>
-              <a:rPr lang="en-US" sz="1700" b="0" dirty="0">
+              <a:rPr lang="en-US" sz="1450" b="0">
                 <a:solidFill>
                   <a:srgbClr val="D4D4D4"/>
                 </a:solidFill>
@@ -5340,7 +5231,7 @@
               <a:t>=</a:t>
             </a:r>
             <a:r>
-              <a:rPr lang="en-US" sz="1700" b="0" dirty="0">
+              <a:rPr lang="en-US" sz="1450" b="0">
                 <a:solidFill>
                   <a:srgbClr val="CCCCCC"/>
                 </a:solidFill>
@@ -5350,136 +5241,56 @@
               <a:t> </a:t>
             </a:r>
             <a:r>
-              <a:rPr lang="en-US" sz="1700" b="0" dirty="0" err="1">
-                <a:solidFill>
-                  <a:srgbClr val="CCCCCC"/>
+              <a:rPr lang="en-US" sz="1450" b="0">
+                <a:solidFill>
+                  <a:srgbClr val="B5CEA8"/>
                 </a:solidFill>
                 <a:effectLst/>
                 <a:latin typeface="Courier"/>
               </a:rPr>
-              <a:t>np.array</a:t>
-            </a:r>
-            <a:r>
-              <a:rPr lang="en-US" sz="1700" b="0" dirty="0">
+              <a:t>2</a:t>
+            </a:r>
+            <a:r>
+              <a:rPr lang="en-US" sz="1450" b="0">
                 <a:solidFill>
                   <a:srgbClr val="CCCCCC"/>
                 </a:solidFill>
                 <a:effectLst/>
                 <a:latin typeface="Courier"/>
               </a:rPr>
-              <a:t>([</a:t>
-            </a:r>
-            <a:r>
-              <a:rPr lang="en-US" sz="1700" b="0" dirty="0">
-                <a:solidFill>
-                  <a:srgbClr val="B5CEA8"/>
+              <a:t> </a:t>
+            </a:r>
+            <a:r>
+              <a:rPr lang="en-US" sz="1450" b="0">
+                <a:solidFill>
+                  <a:srgbClr val="D4D4D4"/>
                 </a:solidFill>
                 <a:effectLst/>
                 <a:latin typeface="Courier"/>
               </a:rPr>
-              <a:t>2</a:t>
-            </a:r>
-            <a:r>
-              <a:rPr lang="en-US" sz="1700" b="0" dirty="0">
+              <a:t>*</a:t>
+            </a:r>
+            <a:r>
+              <a:rPr lang="en-US" sz="1450" b="0">
                 <a:solidFill>
                   <a:srgbClr val="CCCCCC"/>
                 </a:solidFill>
                 <a:effectLst/>
                 <a:latin typeface="Courier"/>
               </a:rPr>
-              <a:t>, </a:t>
-            </a:r>
-            <a:r>
-              <a:rPr lang="en-US" sz="1700" b="0" dirty="0">
-                <a:solidFill>
-                  <a:srgbClr val="B5CEA8"/>
+              <a:t> X.ravel()                     </a:t>
+            </a:r>
+            <a:r>
+              <a:rPr lang="en-US" sz="1450" b="0">
+                <a:solidFill>
+                  <a:srgbClr val="6A9955"/>
                 </a:solidFill>
                 <a:effectLst/>
                 <a:latin typeface="Courier"/>
               </a:rPr>
-              <a:t>4</a:t>
-            </a:r>
-            <a:r>
-              <a:rPr lang="en-US" sz="1700" b="0" dirty="0">
-                <a:solidFill>
-                  <a:srgbClr val="CCCCCC"/>
-                </a:solidFill>
-                <a:effectLst/>
-                <a:latin typeface="Courier"/>
-              </a:rPr>
-              <a:t>, </a:t>
-            </a:r>
-            <a:r>
-              <a:rPr lang="en-US" sz="1700" b="0" dirty="0">
-                <a:solidFill>
-                  <a:srgbClr val="B5CEA8"/>
-                </a:solidFill>
-                <a:effectLst/>
-                <a:latin typeface="Courier"/>
-              </a:rPr>
-              <a:t>6</a:t>
-            </a:r>
-            <a:r>
-              <a:rPr lang="en-US" sz="1700" b="0" dirty="0">
-                <a:solidFill>
-                  <a:srgbClr val="CCCCCC"/>
-                </a:solidFill>
-                <a:effectLst/>
-                <a:latin typeface="Courier"/>
-              </a:rPr>
-              <a:t>, </a:t>
-            </a:r>
-            <a:r>
-              <a:rPr lang="en-US" sz="1700" b="0" dirty="0">
-                <a:solidFill>
-                  <a:srgbClr val="B5CEA8"/>
-                </a:solidFill>
-                <a:effectLst/>
-                <a:latin typeface="Courier"/>
-              </a:rPr>
-              <a:t>8</a:t>
-            </a:r>
-            <a:r>
-              <a:rPr lang="en-US" sz="1700" b="0" dirty="0">
-                <a:solidFill>
-                  <a:srgbClr val="CCCCCC"/>
-                </a:solidFill>
-                <a:effectLst/>
-                <a:latin typeface="Courier"/>
-              </a:rPr>
-              <a:t>, </a:t>
-            </a:r>
-            <a:r>
-              <a:rPr lang="en-US" sz="1700" b="0" dirty="0">
-                <a:solidFill>
-                  <a:srgbClr val="B5CEA8"/>
-                </a:solidFill>
-                <a:effectLst/>
-                <a:latin typeface="Courier"/>
-              </a:rPr>
-              <a:t>10</a:t>
-            </a:r>
-            <a:r>
-              <a:rPr lang="en-US" sz="1700" b="0" dirty="0">
-                <a:solidFill>
-                  <a:srgbClr val="CCCCCC"/>
-                </a:solidFill>
-                <a:effectLst/>
-                <a:latin typeface="Courier"/>
-              </a:rPr>
-              <a:t>])               </a:t>
-            </a:r>
-            <a:r>
-              <a:rPr lang="en-US" sz="1700" b="0" dirty="0">
-                <a:solidFill>
-                  <a:srgbClr val="6A9955"/>
-                </a:solidFill>
-                <a:effectLst/>
-                <a:latin typeface="Courier"/>
-              </a:rPr>
               <a:t># target vector</a:t>
             </a:r>
-            <a:endParaRPr lang="en-US" sz="1700" b="0" dirty="0">
+            <a:endParaRPr lang="en-US" sz="1450" b="0">
               <a:solidFill>
                 <a:srgbClr val="CCCCCC"/>
               </a:solidFill>
@@ -5490,7 +5301,7 @@
           <a:p>
             <a:pPr>
               <a:lnSpc>
-                <a:spcPts val="1425"/>
+                <a:spcPts val="1250"/>
               </a:lnSpc>
               <a:spcAft>
                 <a:spcPts val="200"/>
@@ -5498,7 +5309,7 @@
               <a:buNone/>
             </a:pPr>
             <a:br>
-              <a:rPr lang="en-US" sz="1700" b="0" dirty="0">
+              <a:rPr lang="en-US" sz="1450" b="0">
                 <a:solidFill>
                   <a:srgbClr val="CCCCCC"/>
                 </a:solidFill>
@@ -5506,7 +5317,7 @@
                 <a:latin typeface="Courier"/>
               </a:rPr>
             </a:br>
-            <a:endParaRPr lang="en-US" sz="1700" b="0" dirty="0">
+            <a:endParaRPr lang="en-US" sz="1450" b="0">
               <a:solidFill>
                 <a:srgbClr val="CCCCCC"/>
               </a:solidFill>
@@ -5517,7 +5328,7 @@
           <a:p>
             <a:pPr>
               <a:lnSpc>
-                <a:spcPts val="1425"/>
+                <a:spcPts val="1250"/>
               </a:lnSpc>
               <a:spcAft>
                 <a:spcPts val="200"/>
@@ -5525,16 +5336,16 @@
               <a:buNone/>
             </a:pPr>
             <a:r>
-              <a:rPr lang="en-US" sz="1700" b="0" dirty="0">
+              <a:rPr lang="en-US" sz="1450" b="0">
                 <a:solidFill>
                   <a:srgbClr val="6A9955"/>
                 </a:solidFill>
                 <a:effectLst/>
                 <a:latin typeface="Courier"/>
               </a:rPr>
-              <a:t># Instantiate and fit the model</a:t>
-            </a:r>
-            <a:endParaRPr lang="en-US" sz="1700" b="0" dirty="0">
+              <a:t># Hold out a test set</a:t>
+            </a:r>
+            <a:endParaRPr lang="en-US" sz="1450" b="0">
               <a:solidFill>
                 <a:srgbClr val="CCCCCC"/>
               </a:solidFill>
@@ -5545,7 +5356,7 @@
           <a:p>
             <a:pPr>
               <a:lnSpc>
-                <a:spcPts val="1425"/>
+                <a:spcPts val="1250"/>
               </a:lnSpc>
               <a:spcAft>
                 <a:spcPts val="200"/>
@@ -5553,17 +5364,17 @@
               <a:buNone/>
             </a:pPr>
             <a:r>
-              <a:rPr lang="en-US" sz="1700" b="0" dirty="0">
+              <a:rPr lang="en-US" sz="1450" b="0">
                 <a:solidFill>
                   <a:srgbClr val="CCCCCC"/>
                 </a:solidFill>
                 <a:effectLst/>
                 <a:latin typeface="Courier"/>
               </a:rPr>
-              <a:t>model </a:t>
-            </a:r>
-            <a:r>
-              <a:rPr lang="en-US" sz="1700" b="0" dirty="0">
+              <a:t>X_train, X_test, y_train, y_test </a:t>
+            </a:r>
+            <a:r>
+              <a:rPr lang="en-US" sz="1450" b="0">
                 <a:solidFill>
                   <a:srgbClr val="D4D4D4"/>
                 </a:solidFill>
@@ -5573,7 +5384,7 @@
               <a:t>=</a:t>
             </a:r>
             <a:r>
-              <a:rPr lang="en-US" sz="1700" b="0" dirty="0">
+              <a:rPr lang="en-US" sz="1450" b="0">
                 <a:solidFill>
                   <a:srgbClr val="CCCCCC"/>
                 </a:solidFill>
@@ -5583,77 +5394,106 @@
               <a:t> </a:t>
             </a:r>
             <a:r>
-              <a:rPr lang="en-US" sz="1700" b="0" dirty="0" err="1">
-                <a:solidFill>
-                  <a:srgbClr val="CCCCCC"/>
+              <a:rPr lang="en-US" sz="1450" b="0">
+                <a:solidFill>
+                  <a:srgbClr val="DCDCAA"/>
                 </a:solidFill>
                 <a:effectLst/>
                 <a:latin typeface="Courier"/>
               </a:rPr>
-              <a:t>LinearRegression</a:t>
-            </a:r>
-            <a:r>
-              <a:rPr lang="en-US" sz="1700" b="0" dirty="0">
+              <a:t>train_test_split</a:t>
+            </a:r>
+            <a:r>
+              <a:rPr lang="en-US" sz="1450" b="0">
                 <a:solidFill>
                   <a:srgbClr val="CCCCCC"/>
                 </a:solidFill>
                 <a:effectLst/>
                 <a:latin typeface="Courier"/>
               </a:rPr>
-              <a:t>()</a:t>
+              <a:t>(X, y, test_size</a:t>
+            </a:r>
+            <a:r>
+              <a:rPr lang="en-US" sz="1450" b="0">
+                <a:solidFill>
+                  <a:srgbClr val="D4D4D4"/>
+                </a:solidFill>
+                <a:effectLst/>
+                <a:latin typeface="Courier"/>
+              </a:rPr>
+              <a:t>=</a:t>
+            </a:r>
+            <a:r>
+              <a:rPr lang="en-US" sz="1450" b="0">
+                <a:solidFill>
+                  <a:srgbClr val="B5CEA8"/>
+                </a:solidFill>
+                <a:effectLst/>
+                <a:latin typeface="Courier"/>
+              </a:rPr>
+              <a:t>0.2</a:t>
+            </a:r>
+            <a:r>
+              <a:rPr lang="en-US" sz="1450" b="0">
+                <a:solidFill>
+                  <a:srgbClr val="CCCCCC"/>
+                </a:solidFill>
+                <a:effectLst/>
+                <a:latin typeface="Courier"/>
+              </a:rPr>
+              <a:t>, random_state</a:t>
+            </a:r>
+            <a:r>
+              <a:rPr lang="en-US" sz="1450" b="0">
+                <a:solidFill>
+                  <a:srgbClr val="D4D4D4"/>
+                </a:solidFill>
+                <a:effectLst/>
+                <a:latin typeface="Courier"/>
+              </a:rPr>
+              <a:t>=</a:t>
+            </a:r>
+            <a:r>
+              <a:rPr lang="en-US" sz="1450" b="0">
+                <a:solidFill>
+                  <a:srgbClr val="B5CEA8"/>
+                </a:solidFill>
+                <a:effectLst/>
+                <a:latin typeface="Courier"/>
+              </a:rPr>
+              <a:t>0</a:t>
+            </a:r>
+            <a:r>
+              <a:rPr lang="en-US" sz="1450" b="0">
+                <a:solidFill>
+                  <a:srgbClr val="CCCCCC"/>
+                </a:solidFill>
+                <a:effectLst/>
+                <a:latin typeface="Courier"/>
+              </a:rPr>
+              <a:t>)</a:t>
             </a:r>
           </a:p>
           <a:p>
             <a:pPr>
               <a:lnSpc>
-                <a:spcPts val="1425"/>
+                <a:spcPts val="1250"/>
               </a:lnSpc>
               <a:spcAft>
                 <a:spcPts val="200"/>
               </a:spcAft>
               <a:buNone/>
             </a:pPr>
-            <a:r>
-              <a:rPr lang="en-US" sz="1700" b="0" dirty="0" err="1">
+            <a:br>
+              <a:rPr lang="en-US" sz="1450" b="0">
                 <a:solidFill>
                   <a:srgbClr val="CCCCCC"/>
                 </a:solidFill>
                 <a:effectLst/>
                 <a:latin typeface="Courier"/>
               </a:rPr>
-              <a:t>model.fit</a:t>
-            </a:r>
-            <a:r>
-              <a:rPr lang="en-US" sz="1700" b="0" dirty="0">
-                <a:solidFill>
-                  <a:srgbClr val="CCCCCC"/>
-                </a:solidFill>
-                <a:effectLst/>
-                <a:latin typeface="Courier"/>
-              </a:rPr>
-              <a:t>(X, y)</a:t>
-            </a:r>
-          </a:p>
-          <a:p>
-            <a:pPr>
-              <a:lnSpc>
-                <a:spcPts val="1425"/>
-              </a:lnSpc>
-              <a:spcAft>
-                <a:spcPts val="200"/>
-              </a:spcAft>
-              <a:buNone/>
-            </a:pPr>
-            <a:br>
-              <a:rPr lang="en-US" sz="1700" b="0" dirty="0">
-                <a:solidFill>
-                  <a:srgbClr val="CCCCCC"/>
-                </a:solidFill>
-                <a:effectLst/>
-                <a:latin typeface="Courier"/>
-              </a:rPr>
             </a:br>
-            <a:endParaRPr lang="en-US" sz="1700" b="0" dirty="0">
+            <a:endParaRPr lang="en-US" sz="1450" b="0">
               <a:solidFill>
                 <a:srgbClr val="CCCCCC"/>
               </a:solidFill>
@@ -5664,7 +5504,7 @@
           <a:p>
             <a:pPr>
               <a:lnSpc>
-                <a:spcPts val="1425"/>
+                <a:spcPts val="1250"/>
               </a:lnSpc>
               <a:spcAft>
                 <a:spcPts val="200"/>
@@ -5672,16 +5512,16 @@
               <a:buNone/>
             </a:pPr>
             <a:r>
-              <a:rPr lang="en-US" sz="1700" b="0" dirty="0">
+              <a:rPr lang="en-US" sz="1450" b="0">
                 <a:solidFill>
                   <a:srgbClr val="6A9955"/>
                 </a:solidFill>
                 <a:effectLst/>
                 <a:latin typeface="Courier"/>
               </a:rPr>
-              <a:t># Make predictions</a:t>
-            </a:r>
-            <a:endParaRPr lang="en-US" sz="1700" b="0" dirty="0">
+              <a:t># Fit on the training data only</a:t>
+            </a:r>
+            <a:endParaRPr lang="en-US" sz="1450" b="0">
               <a:solidFill>
                 <a:srgbClr val="CCCCCC"/>
               </a:solidFill>
@@ -5692,7 +5532,7 @@
           <a:p>
             <a:pPr>
               <a:lnSpc>
-                <a:spcPts val="1425"/>
+                <a:spcPts val="1250"/>
               </a:lnSpc>
               <a:spcAft>
                 <a:spcPts val="200"/>
@@ -5700,86 +5540,77 @@
               <a:buNone/>
             </a:pPr>
             <a:r>
-              <a:rPr lang="en-US" sz="1700" b="0" dirty="0" err="1">
+              <a:rPr lang="en-US" sz="1450" b="0">
                 <a:solidFill>
                   <a:srgbClr val="CCCCCC"/>
                 </a:solidFill>
                 <a:effectLst/>
                 <a:latin typeface="Courier"/>
               </a:rPr>
-              <a:t>y_pred</a:t>
-            </a:r>
-            <a:r>
-              <a:rPr lang="en-US" sz="1700" b="0" dirty="0">
-                <a:solidFill>
-                  <a:srgbClr val="CCCCCC"/>
+              <a:t>model </a:t>
+            </a:r>
+            <a:r>
+              <a:rPr lang="en-US" sz="1450" b="0">
+                <a:solidFill>
+                  <a:srgbClr val="D4D4D4"/>
                 </a:solidFill>
                 <a:effectLst/>
                 <a:latin typeface="Courier"/>
               </a:rPr>
-              <a:t> </a:t>
-            </a:r>
-            <a:r>
-              <a:rPr lang="en-US" sz="1700" b="0" dirty="0">
-                <a:solidFill>
-                  <a:srgbClr val="D4D4D4"/>
+              <a:t>=</a:t>
+            </a:r>
+            <a:r>
+              <a:rPr lang="en-US" sz="1450" b="0">
+                <a:solidFill>
+                  <a:srgbClr val="CCCCCC"/>
                 </a:solidFill>
                 <a:effectLst/>
                 <a:latin typeface="Courier"/>
               </a:rPr>
-              <a:t>=</a:t>
-            </a:r>
-            <a:r>
-              <a:rPr lang="en-US" sz="1700" b="0" dirty="0">
-                <a:solidFill>
-                  <a:srgbClr val="CCCCCC"/>
-                </a:solidFill>
-                <a:effectLst/>
-                <a:latin typeface="Courier"/>
-              </a:rPr>
-              <a:t> </a:t>
-            </a:r>
-            <a:r>
-              <a:rPr lang="en-US" sz="1700" b="0" dirty="0" err="1">
-                <a:solidFill>
-                  <a:srgbClr val="CCCCCC"/>
-                </a:solidFill>
-                <a:effectLst/>
-                <a:latin typeface="Courier"/>
-              </a:rPr>
-              <a:t>model.predict</a:t>
-            </a:r>
-            <a:r>
-              <a:rPr lang="en-US" sz="1700" b="0" dirty="0">
-                <a:solidFill>
-                  <a:srgbClr val="CCCCCC"/>
-                </a:solidFill>
-                <a:effectLst/>
-                <a:latin typeface="Courier"/>
-              </a:rPr>
-              <a:t>(X)</a:t>
+              <a:t> LinearRegression()</a:t>
             </a:r>
           </a:p>
           <a:p>
             <a:pPr>
               <a:lnSpc>
-                <a:spcPts val="1425"/>
+                <a:spcPts val="1250"/>
               </a:lnSpc>
               <a:spcAft>
                 <a:spcPts val="200"/>
               </a:spcAft>
               <a:buNone/>
             </a:pPr>
-            <a:br>
-              <a:rPr lang="en-US" sz="1700" b="0" dirty="0">
+            <a:r>
+              <a:rPr lang="en-US" sz="1450" b="0">
                 <a:solidFill>
                   <a:srgbClr val="CCCCCC"/>
                 </a:solidFill>
                 <a:effectLst/>
                 <a:latin typeface="Courier"/>
               </a:rPr>
+              <a:t>model.fit(X_train, y_train)</a:t>
+            </a:r>
+          </a:p>
+          <a:p>
+            <a:pPr>
+              <a:lnSpc>
+                <a:spcPts val="1250"/>
+              </a:lnSpc>
+              <a:spcAft>
+                <a:spcPts val="200"/>
+              </a:spcAft>
+              <a:buNone/>
+            </a:pPr>
+            <a:br>
+              <a:rPr lang="en-US" sz="1450" b="0">
+                <a:solidFill>
+                  <a:srgbClr val="CCCCCC"/>
+                </a:solidFill>
+                <a:effectLst/>
+                <a:latin typeface="Courier"/>
+              </a:rPr>
             </a:br>
-            <a:endParaRPr lang="en-US" sz="1700" b="0" dirty="0">
+            <a:endParaRPr lang="en-US" sz="1450" b="0">
               <a:solidFill>
                 <a:srgbClr val="CCCCCC"/>
               </a:solidFill>
@@ -5790,7 +5621,7 @@
           <a:p>
             <a:pPr>
               <a:lnSpc>
-                <a:spcPts val="1425"/>
+                <a:spcPts val="1250"/>
               </a:lnSpc>
               <a:spcAft>
                 <a:spcPts val="200"/>
@@ -5798,16 +5629,16 @@
               <a:buNone/>
             </a:pPr>
             <a:r>
-              <a:rPr lang="en-US" sz="1700" b="0" dirty="0">
+              <a:rPr lang="en-US" sz="1450" b="0">
                 <a:solidFill>
                   <a:srgbClr val="6A9955"/>
                 </a:solidFill>
                 <a:effectLst/>
                 <a:latin typeface="Courier"/>
               </a:rPr>
-              <a:t># Inspect learned parameters</a:t>
-            </a:r>
-            <a:endParaRPr lang="en-US" sz="1700" b="0" dirty="0">
+              <a:t># Predict on the unseen test data</a:t>
+            </a:r>
+            <a:endParaRPr lang="en-US" sz="1450" b="0">
               <a:solidFill>
                 <a:srgbClr val="CCCCCC"/>
               </a:solidFill>
@@ -5818,7 +5649,7 @@
           <a:p>
             <a:pPr>
               <a:lnSpc>
-                <a:spcPts val="1425"/>
+                <a:spcPts val="1250"/>
               </a:lnSpc>
               <a:spcAft>
                 <a:spcPts val="200"/>
@@ -5826,90 +5657,40 @@
               <a:buNone/>
             </a:pPr>
             <a:r>
-              <a:rPr lang="en-US" sz="1700" b="0" dirty="0">
-                <a:solidFill>
-                  <a:srgbClr val="DCDCAA"/>
+              <a:rPr lang="en-US" sz="1450" b="0">
+                <a:solidFill>
+                  <a:srgbClr val="CCCCCC"/>
                 </a:solidFill>
                 <a:effectLst/>
                 <a:latin typeface="Courier"/>
               </a:rPr>
-              <a:t>print</a:t>
-            </a:r>
-            <a:r>
-              <a:rPr lang="en-US" sz="1700" b="0" dirty="0">
-                <a:solidFill>
-                  <a:srgbClr val="CCCCCC"/>
+              <a:t>y_pred </a:t>
+            </a:r>
+            <a:r>
+              <a:rPr lang="en-US" sz="1450" b="0">
+                <a:solidFill>
+                  <a:srgbClr val="D4D4D4"/>
                 </a:solidFill>
                 <a:effectLst/>
                 <a:latin typeface="Courier"/>
               </a:rPr>
-              <a:t>(</a:t>
-            </a:r>
-            <a:r>
-              <a:rPr lang="en-US" sz="1700" b="0" dirty="0">
-                <a:solidFill>
-                  <a:srgbClr val="CE9178"/>
+              <a:t>=</a:t>
+            </a:r>
+            <a:r>
+              <a:rPr lang="en-US" sz="1450" b="0">
+                <a:solidFill>
+                  <a:srgbClr val="CCCCCC"/>
                 </a:solidFill>
                 <a:effectLst/>
                 <a:latin typeface="Courier"/>
               </a:rPr>
-              <a:t>"Slope:"</a:t>
-            </a:r>
-            <a:r>
-              <a:rPr lang="en-US" sz="1700" b="0" dirty="0">
-                <a:solidFill>
-                  <a:srgbClr val="CCCCCC"/>
-                </a:solidFill>
-                <a:effectLst/>
-                <a:latin typeface="Courier"/>
-              </a:rPr>
-              <a:t>, </a:t>
-            </a:r>
-            <a:r>
-              <a:rPr lang="en-US" sz="1700" b="0" dirty="0" err="1">
-                <a:solidFill>
-                  <a:srgbClr val="CCCCCC"/>
-                </a:solidFill>
-                <a:effectLst/>
-                <a:latin typeface="Courier"/>
-              </a:rPr>
-              <a:t>model.coef</a:t>
-            </a:r>
-            <a:r>
-              <a:rPr lang="en-US" sz="1700" b="0" dirty="0">
-                <a:solidFill>
-                  <a:srgbClr val="CCCCCC"/>
-                </a:solidFill>
-                <a:effectLst/>
-                <a:latin typeface="Courier"/>
-              </a:rPr>
-              <a:t>_[</a:t>
-            </a:r>
-            <a:r>
-              <a:rPr lang="en-US" sz="1700" b="0" dirty="0">
-                <a:solidFill>
-                  <a:srgbClr val="B5CEA8"/>
-                </a:solidFill>
-                <a:effectLst/>
-                <a:latin typeface="Courier"/>
-              </a:rPr>
-              <a:t>0</a:t>
-            </a:r>
-            <a:r>
-              <a:rPr lang="en-US" sz="1700" b="0" dirty="0">
-                <a:solidFill>
-                  <a:srgbClr val="CCCCCC"/>
-                </a:solidFill>
-                <a:effectLst/>
-                <a:latin typeface="Courier"/>
-              </a:rPr>
-              <a:t>])</a:t>
+              <a:t> model.predict(X_test)</a:t>
             </a:r>
           </a:p>
           <a:p>
             <a:pPr>
               <a:lnSpc>
-                <a:spcPts val="1425"/>
+                <a:spcPts val="1250"/>
               </a:lnSpc>
               <a:spcAft>
                 <a:spcPts val="200"/>
@@ -5917,7 +5698,7 @@
               <a:buNone/>
             </a:pPr>
             <a:r>
-              <a:rPr lang="en-US" sz="1700" b="0" dirty="0">
+              <a:rPr lang="en-US" sz="1450" b="0">
                 <a:solidFill>
                   <a:srgbClr val="DCDCAA"/>
                 </a:solidFill>
@@ -5927,7 +5708,7 @@
               <a:t>print</a:t>
             </a:r>
             <a:r>
-              <a:rPr lang="en-US" sz="1700" b="0" dirty="0">
+              <a:rPr lang="en-US" sz="1450" b="0">
                 <a:solidFill>
                   <a:srgbClr val="CCCCCC"/>
                 </a:solidFill>
@@ -5937,72 +5718,96 @@
               <a:t>(</a:t>
             </a:r>
             <a:r>
-              <a:rPr lang="en-US" sz="1700" b="0" dirty="0">
+              <a:rPr lang="en-US" sz="1450" b="0">
                 <a:solidFill>
                   <a:srgbClr val="CE9178"/>
                 </a:solidFill>
                 <a:effectLst/>
                 <a:latin typeface="Courier"/>
               </a:rPr>
-              <a:t>"Intercept:"</a:t>
-            </a:r>
-            <a:r>
-              <a:rPr lang="en-US" sz="1700" b="0" dirty="0">
+              <a:t>"Slope:"</a:t>
+            </a:r>
+            <a:r>
+              <a:rPr lang="en-US" sz="1450" b="0">
                 <a:solidFill>
                   <a:srgbClr val="CCCCCC"/>
                 </a:solidFill>
                 <a:effectLst/>
                 <a:latin typeface="Courier"/>
               </a:rPr>
-              <a:t>, </a:t>
-            </a:r>
-            <a:r>
-              <a:rPr lang="en-US" sz="1700" b="0" dirty="0" err="1">
-                <a:solidFill>
-                  <a:srgbClr val="CCCCCC"/>
+              <a:t>, model.coef_[</a:t>
+            </a:r>
+            <a:r>
+              <a:rPr lang="en-US" sz="1450" b="0">
+                <a:solidFill>
+                  <a:srgbClr val="B5CEA8"/>
                 </a:solidFill>
                 <a:effectLst/>
                 <a:latin typeface="Courier"/>
               </a:rPr>
-              <a:t>model.intercept</a:t>
-            </a:r>
-            <a:r>
-              <a:rPr lang="en-US" sz="1700" b="0" dirty="0">
+              <a:t>0</a:t>
+            </a:r>
+            <a:r>
+              <a:rPr lang="en-US" sz="1450" b="0">
                 <a:solidFill>
                   <a:srgbClr val="CCCCCC"/>
                 </a:solidFill>
                 <a:effectLst/>
                 <a:latin typeface="Courier"/>
               </a:rPr>
-              <a:t>_)</a:t>
+              <a:t>])</a:t>
             </a:r>
           </a:p>
           <a:p>
             <a:pPr>
               <a:lnSpc>
-                <a:spcPts val="1425"/>
+                <a:spcPts val="1250"/>
               </a:lnSpc>
               <a:spcAft>
                 <a:spcPts val="200"/>
               </a:spcAft>
               <a:buNone/>
             </a:pPr>
-            <a:br>
-              <a:rPr lang="en-US" sz="1700" b="0" dirty="0">
-                <a:solidFill>
-                  <a:srgbClr val="CCCCCC"/>
+            <a:r>
+              <a:rPr lang="en-US" sz="1450" b="0">
+                <a:solidFill>
+                  <a:srgbClr val="DCDCAA"/>
                 </a:solidFill>
                 <a:effectLst/>
                 <a:latin typeface="Courier"/>
               </a:rPr>
-            </a:br>
-            <a:endParaRPr lang="en-US" sz="1700" b="0" dirty="0">
-              <a:solidFill>
-                <a:srgbClr val="CCCCCC"/>
-              </a:solidFill>
-              <a:effectLst/>
-              <a:latin typeface="Courier"/>
-            </a:endParaRPr>
+              <a:t>print</a:t>
+            </a:r>
+            <a:r>
+              <a:rPr lang="en-US" sz="1450" b="0">
+                <a:solidFill>
+                  <a:srgbClr val="CCCCCC"/>
+                </a:solidFill>
+                <a:effectLst/>
+                <a:latin typeface="Courier"/>
+              </a:rPr>
+              <a:t>(</a:t>
+            </a:r>
+            <a:r>
+              <a:rPr lang="en-US" sz="1450" b="0">
+                <a:solidFill>
+                  <a:srgbClr val="CE9178"/>
+                </a:solidFill>
+                <a:effectLst/>
+                <a:latin typeface="Courier"/>
+              </a:rPr>
+              <a:t>"Intercept:"</a:t>
+            </a:r>
+            <a:r>
+              <a:rPr lang="en-US" sz="1450" b="0">
+                <a:solidFill>
+                  <a:srgbClr val="CCCCCC"/>
+                </a:solidFill>
+                <a:effectLst/>
+                <a:latin typeface="Courier"/>
+              </a:rPr>
+              <a:t>, model.intercept_)</a:t>
+            </a:r>
           </a:p>
         </p:txBody>
       </p:sp>
@@ -6324,6 +6129,7 @@
               </a:defRPr>
             </a:pPr>
             <a:r>
+              <a:rPr dirty="0"/>
               <a:t>A pipeline treats the full workflow as one estimator:</a:t>
             </a:r>
           </a:p>
@@ -6337,6 +6143,7 @@
               </a:defRPr>
             </a:pPr>
             <a:r>
+              <a:rPr dirty="0"/>
               <a:t>Prevents leakage during train/test splits and cross-validation</a:t>
             </a:r>
           </a:p>
@@ -6350,6 +6157,7 @@
               </a:defRPr>
             </a:pPr>
             <a:r>
+              <a:rPr dirty="0"/>
               <a:t>Applies the same preprocessing to training, validation, and new data</a:t>
             </a:r>
           </a:p>
@@ -6363,33 +6171,8 @@
               </a:defRPr>
             </a:pPr>
             <a:r>
+              <a:rPr dirty="0"/>
               <a:t>Keeps code concise and reproducible: one object for .fit(), .predict(), and .score()</a:t>
-            </a:r>
-          </a:p>
-          <a:p>
-            <a:pPr lvl="1">
-              <a:spcAft>
-                <a:spcPts val="400"/>
-              </a:spcAft>
-              <a:defRPr sz="2200" b="0">
-                <a:latin typeface="Calisto MT"/>
-              </a:defRPr>
-            </a:pPr>
-            <a:r>
-              <a:t>Works directly with cross_val_score and GridSearchCV</a:t>
-            </a:r>
-          </a:p>
-          <a:p>
-            <a:pPr lvl="1">
-              <a:spcAft>
-                <a:spcPts val="400"/>
-              </a:spcAft>
-              <a:defRPr sz="2200" b="0">
-                <a:latin typeface="Calisto MT"/>
-              </a:defRPr>
-            </a:pPr>
-            <a:r>
-              <a:t>Tune step parameters with step__parameter (for example, "model__n_neighbors")</a:t>
             </a:r>
           </a:p>
         </p:txBody>
@@ -7401,7 +7184,7 @@
 </file>
 
 <file path=ppt/slides/slide16.xml><?xml version="1.0" encoding="utf-8"?>
-<p:sld xmlns:a="http://schemas.openxmlformats.org/drawingml/2006/main" xmlns:r="http://schemas.openxmlformats.org/officeDocument/2006/relationships" xmlns:p="http://schemas.openxmlformats.org/presentationml/2006/main">
+<p:sld xmlns:a="http://schemas.openxmlformats.org/drawingml/2006/main" xmlns:r="http://schemas.openxmlformats.org/officeDocument/2006/relationships" xmlns:p="http://schemas.openxmlformats.org/presentationml/2006/main" show="0">
   <p:cSld>
     <p:spTree>
       <p:nvGrpSpPr>
@@ -7642,7 +7425,7 @@
 </file>
 
 <file path=ppt/slides/slide2.xml><?xml version="1.0" encoding="utf-8"?>
-<p:sld xmlns:a="http://schemas.openxmlformats.org/drawingml/2006/main" xmlns:r="http://schemas.openxmlformats.org/officeDocument/2006/relationships" xmlns:p="http://schemas.openxmlformats.org/presentationml/2006/main">
+<p:sld xmlns:a="http://schemas.openxmlformats.org/drawingml/2006/main" xmlns:r="http://schemas.openxmlformats.org/officeDocument/2006/relationships" xmlns:p="http://schemas.openxmlformats.org/presentationml/2006/main" show="0">
   <p:cSld>
     <p:spTree>
       <p:nvGrpSpPr>
@@ -9902,7 +9685,7 @@
           </a:ln>
           <a:extLst>
             <a:ext uri="{C572A759-6A51-4108-AA02-DFA0A04FC94B}">
-              <ma14:wrappingTextBoxFlag xmlns:ma14="http://schemas.microsoft.com/office/mac/drawingml/2011/main" xmlns:a14="http://schemas.microsoft.com/office/drawing/2010/main" xmlns:m="http://schemas.openxmlformats.org/officeDocument/2006/math" xmlns="" val="1"/>
+              <ma14:wrappingTextBoxFlag xmlns="" xmlns:m="http://schemas.openxmlformats.org/officeDocument/2006/math" xmlns:a14="http://schemas.microsoft.com/office/drawing/2010/main" xmlns:ma14="http://schemas.microsoft.com/office/mac/drawingml/2011/main" val="1"/>
             </a:ext>
           </a:extLst>
         </p:spPr>
@@ -9962,7 +9745,7 @@
         <p:spPr>
           <a:xfrm>
             <a:off x="1984579" y="4953451"/>
-            <a:ext cx="8222842" cy="299442"/>
+            <a:ext cx="8222842" cy="352276"/>
           </a:xfrm>
           <a:prstGeom prst="rect">
             <a:avLst/>
@@ -9972,13 +9755,13 @@
           </a:ln>
           <a:extLst>
             <a:ext uri="{C572A759-6A51-4108-AA02-DFA0A04FC94B}">
-              <ma14:wrappingTextBoxFlag xmlns:ma14="http://schemas.microsoft.com/office/mac/drawingml/2011/main" xmlns:a14="http://schemas.microsoft.com/office/drawing/2010/main" xmlns:m="http://schemas.openxmlformats.org/officeDocument/2006/math" xmlns="" val="1"/>
+              <ma14:wrappingTextBoxFlag xmlns="" xmlns:m="http://schemas.openxmlformats.org/officeDocument/2006/math" xmlns:a14="http://schemas.microsoft.com/office/drawing/2010/main" xmlns:ma14="http://schemas.microsoft.com/office/mac/drawingml/2011/main" val="1"/>
             </a:ext>
           </a:extLst>
         </p:spPr>
         <p:txBody>
           <a:bodyPr lIns="35719" tIns="35719" rIns="35719" bIns="35719" anchor="ctr">
-            <a:spAutoFit/>
+            <a:normAutofit/>
           </a:bodyPr>
           <a:lstStyle/>
           <a:p>

</xml_diff>